<commit_message>
Improved content research using dual graph structure one inside the other.flow.png is main graph and worker.png graph for each subtopic
</commit_message>
<xml_diff>
--- a/final_output.pptx
+++ b/final_output.pptx
@@ -12,8 +12,6 @@
     <p:sldId id="260" r:id="rId11"/>
     <p:sldId id="261" r:id="rId12"/>
     <p:sldId id="262" r:id="rId13"/>
-    <p:sldId id="263" r:id="rId14"/>
-    <p:sldId id="264" r:id="rId15"/>
   </p:sldIdLst>
   <p:sldSz cx="12192000" cy="6858000" type="screen4x3"/>
   <p:notesSz cx="6858000" cy="9144000"/>
@@ -3125,7 +3123,7 @@
           <a:lstStyle/>
           <a:p>
             <a:r>
-              <a:t>Tesla vs BYD: A Comparative Analysis of Electric Vehicle Giants</a:t>
+              <a:t>The Rise of Digital Payments in India: A UPI Revolution</a:t>
             </a:r>
           </a:p>
         </p:txBody>
@@ -3153,7 +3151,7 @@
           <p:cNvPr id="2" name="content1">
             <a:extLst>
               <a:ext uri="{FF2B5EF4-FFF2-40B4-BE49-F238E27FC236}">
-                <a16:creationId xmlns:a16="http://schemas.microsoft.com/office/drawing/2014/main" id="{4CFE2BC8-54A5-407E-B141-B5EC04BD3417}"/>
+                <a16:creationId xmlns:a16="http://schemas.microsoft.com/office/drawing/2014/main" id="{54FB0FDB-46CC-42BE-A833-C89184E3471E}"/>
               </a:ext>
             </a:extLst>
           </p:cNvPr>
@@ -3162,8 +3160,8 @@
         </p:nvSpPr>
         <p:spPr>
           <a:xfrm>
-            <a:off x="382842" y="2321170"/>
-            <a:ext cx="8588880" cy="646331"/>
+            <a:off x="350251" y="3043533"/>
+            <a:ext cx="5713159" cy="646331"/>
           </a:xfrm>
           <a:prstGeom prst="rect">
             <a:avLst/>
@@ -3182,7 +3180,7 @@
           <a:lstStyle/>
           <a:p>
             <a:r>
-              <a:t>In 2023, BYD became the global new energy vehicle sales champion, achieving over 3 million annual sales for the second consecutive year.</a:t>
+              <a:t>Digital payments in India evolved through four phases: pre-2010 with NEFT/RTGS, 2010-2015 with mobile wallets and IMPS, 2016-2020 with UPI's launch, and 2020-2024 marked by rapid growth during COVID-19.</a:t>
             </a:r>
           </a:p>
         </p:txBody>
@@ -3192,7 +3190,7 @@
           <p:cNvPr id="3" name="head1">
             <a:extLst>
               <a:ext uri="{FF2B5EF4-FFF2-40B4-BE49-F238E27FC236}">
-                <a16:creationId xmlns:a16="http://schemas.microsoft.com/office/drawing/2014/main" id="{AF43DD1A-697B-4E09-8F47-DB6EB5F90E42}"/>
+                <a16:creationId xmlns:a16="http://schemas.microsoft.com/office/drawing/2014/main" id="{18484F3A-33E9-4106-BBE3-C35CDE75E4F4}"/>
               </a:ext>
             </a:extLst>
           </p:cNvPr>
@@ -3201,8 +3199,8 @@
         </p:nvSpPr>
         <p:spPr>
           <a:xfrm>
-            <a:off x="382842" y="1659451"/>
-            <a:ext cx="8588880" cy="646331"/>
+            <a:off x="350251" y="2441330"/>
+            <a:ext cx="5745749" cy="584775"/>
           </a:xfrm>
           <a:prstGeom prst="rect">
             <a:avLst/>
@@ -3216,17 +3214,17 @@
           <a:lstStyle/>
           <a:p>
             <a:r>
-              <a:t>BYD's Market Leadership</a:t>
-            </a:r>
-          </a:p>
-        </p:txBody>
-      </p:sp>
-      <p:sp>
-        <p:nvSpPr>
-          <p:cNvPr id="5" name="content2">
+              <a:t>Four Phases of Digital Payments</a:t>
+            </a:r>
+          </a:p>
+        </p:txBody>
+      </p:sp>
+      <p:sp>
+        <p:nvSpPr>
+          <p:cNvPr id="4" name="content3">
             <a:extLst>
               <a:ext uri="{FF2B5EF4-FFF2-40B4-BE49-F238E27FC236}">
-                <a16:creationId xmlns:a16="http://schemas.microsoft.com/office/drawing/2014/main" id="{0114294D-3C82-4496-9578-DE3D20CA1765}"/>
+                <a16:creationId xmlns:a16="http://schemas.microsoft.com/office/drawing/2014/main" id="{7ED6F132-1EC3-4F89-ACC9-391787BE6AE2}"/>
               </a:ext>
             </a:extLst>
           </p:cNvPr>
@@ -3235,8 +3233,8 @@
         </p:nvSpPr>
         <p:spPr>
           <a:xfrm>
-            <a:off x="402712" y="3940580"/>
-            <a:ext cx="8569010" cy="646331"/>
+            <a:off x="415434" y="5525002"/>
+            <a:ext cx="5647975" cy="646331"/>
           </a:xfrm>
           <a:prstGeom prst="rect">
             <a:avLst/>
@@ -3255,17 +3253,17 @@
           <a:lstStyle/>
           <a:p>
             <a:r>
-              <a:t>BYD's exports surged by 334.2% in 2023, reaching 242,765 units across over 70 countries, enhancing its global market presence.</a:t>
-            </a:r>
-          </a:p>
-        </p:txBody>
-      </p:sp>
-      <p:sp>
-        <p:nvSpPr>
-          <p:cNvPr id="6" name="head2">
+              <a:t>In 2024, India's digital payment adoption reached 87%, significantly exceeding the global average of 62%, driven by youth engagement and the rise of fintech solutions.</a:t>
+            </a:r>
+          </a:p>
+        </p:txBody>
+      </p:sp>
+      <p:sp>
+        <p:nvSpPr>
+          <p:cNvPr id="5" name="head3">
             <a:extLst>
               <a:ext uri="{FF2B5EF4-FFF2-40B4-BE49-F238E27FC236}">
-                <a16:creationId xmlns:a16="http://schemas.microsoft.com/office/drawing/2014/main" id="{EC54FAE9-D0C9-4E6D-BD92-BE588E00A0E5}"/>
+                <a16:creationId xmlns:a16="http://schemas.microsoft.com/office/drawing/2014/main" id="{1EC6BFD2-A54A-4CFB-BE32-CB35F7C65D66}"/>
               </a:ext>
             </a:extLst>
           </p:cNvPr>
@@ -3274,8 +3272,8 @@
         </p:nvSpPr>
         <p:spPr>
           <a:xfrm>
-            <a:off x="388238" y="3281321"/>
-            <a:ext cx="8583484" cy="646331"/>
+            <a:off x="382842" y="4952327"/>
+            <a:ext cx="5680567" cy="584775"/>
           </a:xfrm>
           <a:prstGeom prst="rect">
             <a:avLst/>
@@ -3289,17 +3287,17 @@
           <a:lstStyle/>
           <a:p>
             <a:r>
-              <a:t>International Expansion</a:t>
-            </a:r>
-          </a:p>
-        </p:txBody>
-      </p:sp>
-      <p:sp>
-        <p:nvSpPr>
-          <p:cNvPr id="7" name="content3">
+              <a:t>High Adoption Rates</a:t>
+            </a:r>
+          </a:p>
+        </p:txBody>
+      </p:sp>
+      <p:sp>
+        <p:nvSpPr>
+          <p:cNvPr id="6" name="content2">
             <a:extLst>
               <a:ext uri="{FF2B5EF4-FFF2-40B4-BE49-F238E27FC236}">
-                <a16:creationId xmlns:a16="http://schemas.microsoft.com/office/drawing/2014/main" id="{BAB09B8F-FCBE-446C-89AD-F3E542DDA470}"/>
+                <a16:creationId xmlns:a16="http://schemas.microsoft.com/office/drawing/2014/main" id="{228BCD66-C14B-42CD-A438-BC7AA99965CD}"/>
               </a:ext>
             </a:extLst>
           </p:cNvPr>
@@ -3308,8 +3306,8 @@
         </p:nvSpPr>
         <p:spPr>
           <a:xfrm>
-            <a:off x="382842" y="5566061"/>
-            <a:ext cx="8583484" cy="646331"/>
+            <a:off x="6374296" y="3043533"/>
+            <a:ext cx="5148396" cy="646331"/>
           </a:xfrm>
           <a:prstGeom prst="rect">
             <a:avLst/>
@@ -3328,17 +3326,17 @@
           <a:lstStyle/>
           <a:p>
             <a:r>
-              <a:t>BYD boasts an extensive brand matrix, including the Dynasty and Ocean series, solidifying its position in the global new energy sector.</a:t>
-            </a:r>
-          </a:p>
-        </p:txBody>
-      </p:sp>
-      <p:sp>
-        <p:nvSpPr>
-          <p:cNvPr id="8" name="head3">
+              <a:t>By December 2024, UPI achieved an impressive 16.73 billion transactions, reflecting its pivotal role in India's digital payment landscape and the surge in total digital transaction value to ₹2,428,200 billion.</a:t>
+            </a:r>
+          </a:p>
+        </p:txBody>
+      </p:sp>
+      <p:sp>
+        <p:nvSpPr>
+          <p:cNvPr id="7" name="head2">
             <a:extLst>
               <a:ext uri="{FF2B5EF4-FFF2-40B4-BE49-F238E27FC236}">
-                <a16:creationId xmlns:a16="http://schemas.microsoft.com/office/drawing/2014/main" id="{7F46E3E4-B57E-4E3B-ABC9-C8472D45B500}"/>
+                <a16:creationId xmlns:a16="http://schemas.microsoft.com/office/drawing/2014/main" id="{CD5BF12C-71C8-4652-9154-19F255752D5D}"/>
               </a:ext>
             </a:extLst>
           </p:cNvPr>
@@ -3347,8 +3345,8 @@
         </p:nvSpPr>
         <p:spPr>
           <a:xfrm>
-            <a:off x="388238" y="4900731"/>
-            <a:ext cx="8588880" cy="646331"/>
+            <a:off x="6341705" y="2441330"/>
+            <a:ext cx="5180986" cy="584775"/>
           </a:xfrm>
           <a:prstGeom prst="rect">
             <a:avLst/>
@@ -3362,17 +3360,17 @@
           <a:lstStyle/>
           <a:p>
             <a:r>
-              <a:t>Diverse Product Portfolio</a:t>
-            </a:r>
-          </a:p>
-        </p:txBody>
-      </p:sp>
-      <p:sp>
-        <p:nvSpPr>
-          <p:cNvPr id="4" name="subtopic">
+              <a:t>UPI's Transaction Milestone</a:t>
+            </a:r>
+          </a:p>
+        </p:txBody>
+      </p:sp>
+      <p:sp>
+        <p:nvSpPr>
+          <p:cNvPr id="9" name="head4">
             <a:extLst>
               <a:ext uri="{FF2B5EF4-FFF2-40B4-BE49-F238E27FC236}">
-                <a16:creationId xmlns:a16="http://schemas.microsoft.com/office/drawing/2014/main" id="{216BD8E4-BE8C-48D9-AFBB-D6093A341E66}"/>
+                <a16:creationId xmlns:a16="http://schemas.microsoft.com/office/drawing/2014/main" id="{B5F1E050-5BFC-480A-9E92-7665641E2034}"/>
               </a:ext>
             </a:extLst>
           </p:cNvPr>
@@ -3381,8 +3379,42 @@
         </p:nvSpPr>
         <p:spPr>
           <a:xfrm>
-            <a:off x="382842" y="202185"/>
-            <a:ext cx="10863056" cy="646331"/>
+            <a:off x="6341705" y="4952327"/>
+            <a:ext cx="5180986" cy="584775"/>
+          </a:xfrm>
+          <a:prstGeom prst="rect">
+            <a:avLst/>
+          </a:prstGeom>
+          <a:noFill/>
+        </p:spPr>
+        <p:txBody>
+          <a:bodyPr wrap="square" rtlCol="0">
+            <a:spAutoFit/>
+          </a:bodyPr>
+          <a:lstStyle/>
+          <a:p>
+            <a:r>
+              <a:t>Enhancing Financial Inclusion</a:t>
+            </a:r>
+          </a:p>
+        </p:txBody>
+      </p:sp>
+      <p:sp>
+        <p:nvSpPr>
+          <p:cNvPr id="21" name="content4">
+            <a:extLst>
+              <a:ext uri="{FF2B5EF4-FFF2-40B4-BE49-F238E27FC236}">
+                <a16:creationId xmlns:a16="http://schemas.microsoft.com/office/drawing/2014/main" id="{CFBB8D88-C46B-4BFD-95E5-3CD2F79AB4A3}"/>
+              </a:ext>
+            </a:extLst>
+          </p:cNvPr>
+          <p:cNvSpPr txBox="1"/>
+          <p:nvPr/>
+        </p:nvSpPr>
+        <p:spPr>
+          <a:xfrm>
+            <a:off x="6374296" y="5537102"/>
+            <a:ext cx="5148396" cy="646331"/>
           </a:xfrm>
           <a:prstGeom prst="rect">
             <a:avLst/>
@@ -3401,7 +3433,41 @@
           <a:lstStyle/>
           <a:p>
             <a:r>
-              <a:t>Overview of Tesla and BYD: Company Histories and Market Positions</a:t>
+              <a:t>UPI has significantly improved financial inclusion, especially for low-income households and small merchants, by simplifying transactions and expanding access to formal financial services.</a:t>
+            </a:r>
+          </a:p>
+        </p:txBody>
+      </p:sp>
+      <p:sp>
+        <p:nvSpPr>
+          <p:cNvPr id="27" name="subtopic">
+            <a:extLst>
+              <a:ext uri="{FF2B5EF4-FFF2-40B4-BE49-F238E27FC236}">
+                <a16:creationId xmlns:a16="http://schemas.microsoft.com/office/drawing/2014/main" id="{1FC39E55-DAC2-4D18-8701-DF4E171179AC}"/>
+              </a:ext>
+            </a:extLst>
+          </p:cNvPr>
+          <p:cNvSpPr txBox="1"/>
+          <p:nvPr/>
+        </p:nvSpPr>
+        <p:spPr>
+          <a:xfrm>
+            <a:off x="168257" y="330442"/>
+            <a:ext cx="10563455" cy="646331"/>
+          </a:xfrm>
+          <a:prstGeom prst="rect">
+            <a:avLst/>
+          </a:prstGeom>
+          <a:noFill/>
+        </p:spPr>
+        <p:txBody>
+          <a:bodyPr wrap="square" rtlCol="0">
+            <a:spAutoFit/>
+          </a:bodyPr>
+          <a:lstStyle/>
+          <a:p>
+            <a:r>
+              <a:t>The Evolution of Digital Payments in India: From Cash to UPI</a:t>
             </a:r>
           </a:p>
         </p:txBody>
@@ -3429,7 +3495,7 @@
           <p:cNvPr id="2" name="content1">
             <a:extLst>
               <a:ext uri="{FF2B5EF4-FFF2-40B4-BE49-F238E27FC236}">
-                <a16:creationId xmlns:a16="http://schemas.microsoft.com/office/drawing/2014/main" id="{4CFE2BC8-54A5-407E-B141-B5EC04BD3417}"/>
+                <a16:creationId xmlns:a16="http://schemas.microsoft.com/office/drawing/2014/main" id="{54FB0FDB-46CC-42BE-A833-C89184E3471E}"/>
               </a:ext>
             </a:extLst>
           </p:cNvPr>
@@ -3438,8 +3504,8 @@
         </p:nvSpPr>
         <p:spPr>
           <a:xfrm>
-            <a:off x="382842" y="2321170"/>
-            <a:ext cx="8588880" cy="646331"/>
+            <a:off x="350251" y="3043533"/>
+            <a:ext cx="5713159" cy="646331"/>
           </a:xfrm>
           <a:prstGeom prst="rect">
             <a:avLst/>
@@ -3458,7 +3524,7 @@
           <a:lstStyle/>
           <a:p>
             <a:r>
-              <a:t>BYD sold approximately 3 million cars in 2023, with a forecast of 4 million, while Tesla experienced a year-over-year sales decline in early 2024.</a:t>
+              <a:t>UPI's open architecture enables seamless interoperability among banks and payment providers, enhancing user convenience in digital transactions.</a:t>
             </a:r>
           </a:p>
         </p:txBody>
@@ -3468,7 +3534,7 @@
           <p:cNvPr id="3" name="head1">
             <a:extLst>
               <a:ext uri="{FF2B5EF4-FFF2-40B4-BE49-F238E27FC236}">
-                <a16:creationId xmlns:a16="http://schemas.microsoft.com/office/drawing/2014/main" id="{AF43DD1A-697B-4E09-8F47-DB6EB5F90E42}"/>
+                <a16:creationId xmlns:a16="http://schemas.microsoft.com/office/drawing/2014/main" id="{18484F3A-33E9-4106-BBE3-C35CDE75E4F4}"/>
               </a:ext>
             </a:extLst>
           </p:cNvPr>
@@ -3477,8 +3543,8 @@
         </p:nvSpPr>
         <p:spPr>
           <a:xfrm>
-            <a:off x="382842" y="1659451"/>
-            <a:ext cx="8588880" cy="646331"/>
+            <a:off x="350251" y="2441330"/>
+            <a:ext cx="5745749" cy="584775"/>
           </a:xfrm>
           <a:prstGeom prst="rect">
             <a:avLst/>
@@ -3492,17 +3558,17 @@
           <a:lstStyle/>
           <a:p>
             <a:r>
-              <a:t>Sales Performance</a:t>
-            </a:r>
-          </a:p>
-        </p:txBody>
-      </p:sp>
-      <p:sp>
-        <p:nvSpPr>
-          <p:cNvPr id="5" name="content2">
+              <a:t>Open Architecture Infrastructure</a:t>
+            </a:r>
+          </a:p>
+        </p:txBody>
+      </p:sp>
+      <p:sp>
+        <p:nvSpPr>
+          <p:cNvPr id="4" name="content3">
             <a:extLst>
               <a:ext uri="{FF2B5EF4-FFF2-40B4-BE49-F238E27FC236}">
-                <a16:creationId xmlns:a16="http://schemas.microsoft.com/office/drawing/2014/main" id="{0114294D-3C82-4496-9578-DE3D20CA1765}"/>
+                <a16:creationId xmlns:a16="http://schemas.microsoft.com/office/drawing/2014/main" id="{7ED6F132-1EC3-4F89-ACC9-391787BE6AE2}"/>
               </a:ext>
             </a:extLst>
           </p:cNvPr>
@@ -3511,8 +3577,8 @@
         </p:nvSpPr>
         <p:spPr>
           <a:xfrm>
-            <a:off x="402712" y="3940580"/>
-            <a:ext cx="8569010" cy="646331"/>
+            <a:off x="415434" y="5525002"/>
+            <a:ext cx="5647975" cy="646331"/>
           </a:xfrm>
           <a:prstGeom prst="rect">
             <a:avLst/>
@@ -3531,17 +3597,17 @@
           <a:lstStyle/>
           <a:p>
             <a:r>
-              <a:t>BYD drives down costs through vertical integration, enhancing its competitive edge in the EV market.</a:t>
-            </a:r>
-          </a:p>
-        </p:txBody>
-      </p:sp>
-      <p:sp>
-        <p:nvSpPr>
-          <p:cNvPr id="6" name="head2">
+              <a:t>Recent UPI advancements allow credit card payments directly within the platform, catering to users who prefer credit over debit transactions.</a:t>
+            </a:r>
+          </a:p>
+        </p:txBody>
+      </p:sp>
+      <p:sp>
+        <p:nvSpPr>
+          <p:cNvPr id="5" name="head3">
             <a:extLst>
               <a:ext uri="{FF2B5EF4-FFF2-40B4-BE49-F238E27FC236}">
-                <a16:creationId xmlns:a16="http://schemas.microsoft.com/office/drawing/2014/main" id="{EC54FAE9-D0C9-4E6D-BD92-BE588E00A0E5}"/>
+                <a16:creationId xmlns:a16="http://schemas.microsoft.com/office/drawing/2014/main" id="{1EC6BFD2-A54A-4CFB-BE32-CB35F7C65D66}"/>
               </a:ext>
             </a:extLst>
           </p:cNvPr>
@@ -3550,8 +3616,8 @@
         </p:nvSpPr>
         <p:spPr>
           <a:xfrm>
-            <a:off x="388238" y="3281321"/>
-            <a:ext cx="8583484" cy="646331"/>
+            <a:off x="382842" y="4952327"/>
+            <a:ext cx="5680567" cy="584775"/>
           </a:xfrm>
           <a:prstGeom prst="rect">
             <a:avLst/>
@@ -3565,17 +3631,17 @@
           <a:lstStyle/>
           <a:p>
             <a:r>
-              <a:t>Vertical Integration</a:t>
-            </a:r>
-          </a:p>
-        </p:txBody>
-      </p:sp>
-      <p:sp>
-        <p:nvSpPr>
-          <p:cNvPr id="7" name="content3">
+              <a:t>Integration of Credit Cards</a:t>
+            </a:r>
+          </a:p>
+        </p:txBody>
+      </p:sp>
+      <p:sp>
+        <p:nvSpPr>
+          <p:cNvPr id="6" name="content2">
             <a:extLst>
               <a:ext uri="{FF2B5EF4-FFF2-40B4-BE49-F238E27FC236}">
-                <a16:creationId xmlns:a16="http://schemas.microsoft.com/office/drawing/2014/main" id="{BAB09B8F-FCBE-446C-89AD-F3E542DDA470}"/>
+                <a16:creationId xmlns:a16="http://schemas.microsoft.com/office/drawing/2014/main" id="{228BCD66-C14B-42CD-A438-BC7AA99965CD}"/>
               </a:ext>
             </a:extLst>
           </p:cNvPr>
@@ -3584,8 +3650,8 @@
         </p:nvSpPr>
         <p:spPr>
           <a:xfrm>
-            <a:off x="382842" y="5566061"/>
-            <a:ext cx="8583484" cy="646331"/>
+            <a:off x="6374296" y="3043533"/>
+            <a:ext cx="5148396" cy="646331"/>
           </a:xfrm>
           <a:prstGeom prst="rect">
             <a:avLst/>
@@ -3604,17 +3670,17 @@
           <a:lstStyle/>
           <a:p>
             <a:r>
-              <a:t>BYD is one of the largest battery manufacturers, contributing to a significant cost advantage in China's EV sector.</a:t>
-            </a:r>
-          </a:p>
-        </p:txBody>
-      </p:sp>
-      <p:sp>
-        <p:nvSpPr>
-          <p:cNvPr id="8" name="head3">
+              <a:t>Key UPI innovations include single-click payments, virtual addresses, and recurring payment setups, simplifying transactions and improving user experience.</a:t>
+            </a:r>
+          </a:p>
+        </p:txBody>
+      </p:sp>
+      <p:sp>
+        <p:nvSpPr>
+          <p:cNvPr id="7" name="head2">
             <a:extLst>
               <a:ext uri="{FF2B5EF4-FFF2-40B4-BE49-F238E27FC236}">
-                <a16:creationId xmlns:a16="http://schemas.microsoft.com/office/drawing/2014/main" id="{7F46E3E4-B57E-4E3B-ABC9-C8472D45B500}"/>
+                <a16:creationId xmlns:a16="http://schemas.microsoft.com/office/drawing/2014/main" id="{CD5BF12C-71C8-4652-9154-19F255752D5D}"/>
               </a:ext>
             </a:extLst>
           </p:cNvPr>
@@ -3623,8 +3689,8 @@
         </p:nvSpPr>
         <p:spPr>
           <a:xfrm>
-            <a:off x="388238" y="4900731"/>
-            <a:ext cx="8588880" cy="646331"/>
+            <a:off x="6341705" y="2441330"/>
+            <a:ext cx="5180986" cy="584775"/>
           </a:xfrm>
           <a:prstGeom prst="rect">
             <a:avLst/>
@@ -3638,17 +3704,17 @@
           <a:lstStyle/>
           <a:p>
             <a:r>
-              <a:t>Battery Manufacturing</a:t>
-            </a:r>
-          </a:p>
-        </p:txBody>
-      </p:sp>
-      <p:sp>
-        <p:nvSpPr>
-          <p:cNvPr id="4" name="subtopic">
+              <a:t>Innovative Payment Features</a:t>
+            </a:r>
+          </a:p>
+        </p:txBody>
+      </p:sp>
+      <p:sp>
+        <p:nvSpPr>
+          <p:cNvPr id="9" name="head4">
             <a:extLst>
               <a:ext uri="{FF2B5EF4-FFF2-40B4-BE49-F238E27FC236}">
-                <a16:creationId xmlns:a16="http://schemas.microsoft.com/office/drawing/2014/main" id="{216BD8E4-BE8C-48D9-AFBB-D6093A341E66}"/>
+                <a16:creationId xmlns:a16="http://schemas.microsoft.com/office/drawing/2014/main" id="{B5F1E050-5BFC-480A-9E92-7665641E2034}"/>
               </a:ext>
             </a:extLst>
           </p:cNvPr>
@@ -3657,8 +3723,42 @@
         </p:nvSpPr>
         <p:spPr>
           <a:xfrm>
-            <a:off x="382842" y="202185"/>
-            <a:ext cx="10863056" cy="646331"/>
+            <a:off x="6341705" y="4952327"/>
+            <a:ext cx="5180986" cy="584775"/>
+          </a:xfrm>
+          <a:prstGeom prst="rect">
+            <a:avLst/>
+          </a:prstGeom>
+          <a:noFill/>
+        </p:spPr>
+        <p:txBody>
+          <a:bodyPr wrap="square" rtlCol="0">
+            <a:spAutoFit/>
+          </a:bodyPr>
+          <a:lstStyle/>
+          <a:p>
+            <a:r>
+              <a:t>Global Expansion of UPI</a:t>
+            </a:r>
+          </a:p>
+        </p:txBody>
+      </p:sp>
+      <p:sp>
+        <p:nvSpPr>
+          <p:cNvPr id="21" name="content4">
+            <a:extLst>
+              <a:ext uri="{FF2B5EF4-FFF2-40B4-BE49-F238E27FC236}">
+                <a16:creationId xmlns:a16="http://schemas.microsoft.com/office/drawing/2014/main" id="{CFBB8D88-C46B-4BFD-95E5-3CD2F79AB4A3}"/>
+              </a:ext>
+            </a:extLst>
+          </p:cNvPr>
+          <p:cNvSpPr txBox="1"/>
+          <p:nvPr/>
+        </p:nvSpPr>
+        <p:spPr>
+          <a:xfrm>
+            <a:off x="6374296" y="5537102"/>
+            <a:ext cx="5148396" cy="646331"/>
           </a:xfrm>
           <a:prstGeom prst="rect">
             <a:avLst/>
@@ -3677,7 +3777,41 @@
           <a:lstStyle/>
           <a:p>
             <a:r>
-              <a:t>Technological Innovations: Comparing EV Technologies and Features</a:t>
+              <a:t>UPI's services have expanded to countries like Singapore, UAE, and Nepal, showcasing its potential as a global model for real-time payment systems.</a:t>
+            </a:r>
+          </a:p>
+        </p:txBody>
+      </p:sp>
+      <p:sp>
+        <p:nvSpPr>
+          <p:cNvPr id="27" name="subtopic">
+            <a:extLst>
+              <a:ext uri="{FF2B5EF4-FFF2-40B4-BE49-F238E27FC236}">
+                <a16:creationId xmlns:a16="http://schemas.microsoft.com/office/drawing/2014/main" id="{1FC39E55-DAC2-4D18-8701-DF4E171179AC}"/>
+              </a:ext>
+            </a:extLst>
+          </p:cNvPr>
+          <p:cNvSpPr txBox="1"/>
+          <p:nvPr/>
+        </p:nvSpPr>
+        <p:spPr>
+          <a:xfrm>
+            <a:off x="168257" y="330442"/>
+            <a:ext cx="10563455" cy="646331"/>
+          </a:xfrm>
+          <a:prstGeom prst="rect">
+            <a:avLst/>
+          </a:prstGeom>
+          <a:noFill/>
+        </p:spPr>
+        <p:txBody>
+          <a:bodyPr wrap="square" rtlCol="0">
+            <a:spAutoFit/>
+          </a:bodyPr>
+          <a:lstStyle/>
+          <a:p>
+            <a:r>
+              <a:t>Key Features and Innovations of UPI: How It Works</a:t>
             </a:r>
           </a:p>
         </p:txBody>
@@ -3705,7 +3839,7 @@
           <p:cNvPr id="2" name="content1">
             <a:extLst>
               <a:ext uri="{FF2B5EF4-FFF2-40B4-BE49-F238E27FC236}">
-                <a16:creationId xmlns:a16="http://schemas.microsoft.com/office/drawing/2014/main" id="{4CFE2BC8-54A5-407E-B141-B5EC04BD3417}"/>
+                <a16:creationId xmlns:a16="http://schemas.microsoft.com/office/drawing/2014/main" id="{54FB0FDB-46CC-42BE-A833-C89184E3471E}"/>
               </a:ext>
             </a:extLst>
           </p:cNvPr>
@@ -3714,8 +3848,8 @@
         </p:nvSpPr>
         <p:spPr>
           <a:xfrm>
-            <a:off x="382842" y="2321170"/>
-            <a:ext cx="8588880" cy="646331"/>
+            <a:off x="350251" y="3043533"/>
+            <a:ext cx="5713159" cy="646331"/>
           </a:xfrm>
           <a:prstGeom prst="rect">
             <a:avLst/>
@@ -3734,7 +3868,7 @@
           <a:lstStyle/>
           <a:p>
             <a:r>
-              <a:t>BYD surpassed Tesla in production volume in 2024, producing 1,777,965 battery electric vehicles (BEVs).</a:t>
+              <a:t>UPI has boosted India's Financial Inclusion Index from 43.4 in 2017 to 64.2 in 2024, enhancing access to financial services for low-income households and small merchants.</a:t>
             </a:r>
           </a:p>
         </p:txBody>
@@ -3744,7 +3878,7 @@
           <p:cNvPr id="3" name="head1">
             <a:extLst>
               <a:ext uri="{FF2B5EF4-FFF2-40B4-BE49-F238E27FC236}">
-                <a16:creationId xmlns:a16="http://schemas.microsoft.com/office/drawing/2014/main" id="{AF43DD1A-697B-4E09-8F47-DB6EB5F90E42}"/>
+                <a16:creationId xmlns:a16="http://schemas.microsoft.com/office/drawing/2014/main" id="{18484F3A-33E9-4106-BBE3-C35CDE75E4F4}"/>
               </a:ext>
             </a:extLst>
           </p:cNvPr>
@@ -3753,8 +3887,8 @@
         </p:nvSpPr>
         <p:spPr>
           <a:xfrm>
-            <a:off x="382842" y="1659451"/>
-            <a:ext cx="8588880" cy="646331"/>
+            <a:off x="350251" y="2441330"/>
+            <a:ext cx="5745749" cy="584775"/>
           </a:xfrm>
           <a:prstGeom prst="rect">
             <a:avLst/>
@@ -3768,17 +3902,17 @@
           <a:lstStyle/>
           <a:p>
             <a:r>
-              <a:t>Production Volume</a:t>
-            </a:r>
-          </a:p>
-        </p:txBody>
-      </p:sp>
-      <p:sp>
-        <p:nvSpPr>
-          <p:cNvPr id="5" name="content2">
+              <a:t>Advancement in Financial Inclusion</a:t>
+            </a:r>
+          </a:p>
+        </p:txBody>
+      </p:sp>
+      <p:sp>
+        <p:nvSpPr>
+          <p:cNvPr id="4" name="content3">
             <a:extLst>
               <a:ext uri="{FF2B5EF4-FFF2-40B4-BE49-F238E27FC236}">
-                <a16:creationId xmlns:a16="http://schemas.microsoft.com/office/drawing/2014/main" id="{0114294D-3C82-4496-9578-DE3D20CA1765}"/>
+                <a16:creationId xmlns:a16="http://schemas.microsoft.com/office/drawing/2014/main" id="{7ED6F132-1EC3-4F89-ACC9-391787BE6AE2}"/>
               </a:ext>
             </a:extLst>
           </p:cNvPr>
@@ -3787,8 +3921,8 @@
         </p:nvSpPr>
         <p:spPr>
           <a:xfrm>
-            <a:off x="402712" y="3940580"/>
-            <a:ext cx="8569010" cy="646331"/>
+            <a:off x="415434" y="5525002"/>
+            <a:ext cx="5647975" cy="646331"/>
           </a:xfrm>
           <a:prstGeom prst="rect">
             <a:avLst/>
@@ -3807,17 +3941,17 @@
           <a:lstStyle/>
           <a:p>
             <a:r>
-              <a:t>Tesla led in sales with 1.79 million units sold in 2024, slightly ahead of BYD's 1.76 million units.</a:t>
-            </a:r>
-          </a:p>
-        </p:txBody>
-      </p:sp>
-      <p:sp>
-        <p:nvSpPr>
-          <p:cNvPr id="6" name="head2">
+              <a:t>Since its launch, UPI has saved the Indian economy approximately $67 billion and is projected to increase GDP by $45.6 billion (1.12%) by 2026.</a:t>
+            </a:r>
+          </a:p>
+        </p:txBody>
+      </p:sp>
+      <p:sp>
+        <p:nvSpPr>
+          <p:cNvPr id="5" name="head3">
             <a:extLst>
               <a:ext uri="{FF2B5EF4-FFF2-40B4-BE49-F238E27FC236}">
-                <a16:creationId xmlns:a16="http://schemas.microsoft.com/office/drawing/2014/main" id="{EC54FAE9-D0C9-4E6D-BD92-BE588E00A0E5}"/>
+                <a16:creationId xmlns:a16="http://schemas.microsoft.com/office/drawing/2014/main" id="{1EC6BFD2-A54A-4CFB-BE32-CB35F7C65D66}"/>
               </a:ext>
             </a:extLst>
           </p:cNvPr>
@@ -3826,8 +3960,8 @@
         </p:nvSpPr>
         <p:spPr>
           <a:xfrm>
-            <a:off x="388238" y="3281321"/>
-            <a:ext cx="8583484" cy="646331"/>
+            <a:off x="382842" y="4952327"/>
+            <a:ext cx="5680567" cy="584775"/>
           </a:xfrm>
           <a:prstGeom prst="rect">
             <a:avLst/>
@@ -3841,17 +3975,17 @@
           <a:lstStyle/>
           <a:p>
             <a:r>
-              <a:t>Sales Performance</a:t>
-            </a:r>
-          </a:p>
-        </p:txBody>
-      </p:sp>
-      <p:sp>
-        <p:nvSpPr>
-          <p:cNvPr id="7" name="content3">
+              <a:t>Significant Economic Contributions</a:t>
+            </a:r>
+          </a:p>
+        </p:txBody>
+      </p:sp>
+      <p:sp>
+        <p:nvSpPr>
+          <p:cNvPr id="6" name="content2">
             <a:extLst>
               <a:ext uri="{FF2B5EF4-FFF2-40B4-BE49-F238E27FC236}">
-                <a16:creationId xmlns:a16="http://schemas.microsoft.com/office/drawing/2014/main" id="{BAB09B8F-FCBE-446C-89AD-F3E542DDA470}"/>
+                <a16:creationId xmlns:a16="http://schemas.microsoft.com/office/drawing/2014/main" id="{228BCD66-C14B-42CD-A438-BC7AA99965CD}"/>
               </a:ext>
             </a:extLst>
           </p:cNvPr>
@@ -3860,8 +3994,8 @@
         </p:nvSpPr>
         <p:spPr>
           <a:xfrm>
-            <a:off x="382842" y="5566061"/>
-            <a:ext cx="8583484" cy="646331"/>
+            <a:off x="6374296" y="3043533"/>
+            <a:ext cx="5148396" cy="646331"/>
           </a:xfrm>
           <a:prstGeom prst="rect">
             <a:avLst/>
@@ -3880,17 +4014,17 @@
           <a:lstStyle/>
           <a:p>
             <a:r>
-              <a:t>BYD is projected to become the sole global sales leader in the electric vehicle sector by 2025, overtaking Tesla.</a:t>
-            </a:r>
-          </a:p>
-        </p:txBody>
-      </p:sp>
-      <p:sp>
-        <p:nvSpPr>
-          <p:cNvPr id="8" name="head3">
+              <a:t>UPI transactions soared from 0.09 million in July 2016 to over 16.7 billion by December 2024, integrating underserved populations into the formal economy.</a:t>
+            </a:r>
+          </a:p>
+        </p:txBody>
+      </p:sp>
+      <p:sp>
+        <p:nvSpPr>
+          <p:cNvPr id="7" name="head2">
             <a:extLst>
               <a:ext uri="{FF2B5EF4-FFF2-40B4-BE49-F238E27FC236}">
-                <a16:creationId xmlns:a16="http://schemas.microsoft.com/office/drawing/2014/main" id="{7F46E3E4-B57E-4E3B-ABC9-C8472D45B500}"/>
+                <a16:creationId xmlns:a16="http://schemas.microsoft.com/office/drawing/2014/main" id="{CD5BF12C-71C8-4652-9154-19F255752D5D}"/>
               </a:ext>
             </a:extLst>
           </p:cNvPr>
@@ -3899,8 +4033,8 @@
         </p:nvSpPr>
         <p:spPr>
           <a:xfrm>
-            <a:off x="388238" y="4900731"/>
-            <a:ext cx="8588880" cy="646331"/>
+            <a:off x="6341705" y="2441330"/>
+            <a:ext cx="5180986" cy="584775"/>
           </a:xfrm>
           <a:prstGeom prst="rect">
             <a:avLst/>
@@ -3914,17 +4048,17 @@
           <a:lstStyle/>
           <a:p>
             <a:r>
-              <a:t>Market Leadership Shift</a:t>
-            </a:r>
-          </a:p>
-        </p:txBody>
-      </p:sp>
-      <p:sp>
-        <p:nvSpPr>
-          <p:cNvPr id="4" name="subtopic">
+              <a:t>Surge in Transaction Volumes</a:t>
+            </a:r>
+          </a:p>
+        </p:txBody>
+      </p:sp>
+      <p:sp>
+        <p:nvSpPr>
+          <p:cNvPr id="9" name="head4">
             <a:extLst>
               <a:ext uri="{FF2B5EF4-FFF2-40B4-BE49-F238E27FC236}">
-                <a16:creationId xmlns:a16="http://schemas.microsoft.com/office/drawing/2014/main" id="{216BD8E4-BE8C-48D9-AFBB-D6093A341E66}"/>
+                <a16:creationId xmlns:a16="http://schemas.microsoft.com/office/drawing/2014/main" id="{B5F1E050-5BFC-480A-9E92-7665641E2034}"/>
               </a:ext>
             </a:extLst>
           </p:cNvPr>
@@ -3933,8 +4067,42 @@
         </p:nvSpPr>
         <p:spPr>
           <a:xfrm>
-            <a:off x="382842" y="202185"/>
-            <a:ext cx="10863056" cy="646331"/>
+            <a:off x="6341705" y="4952327"/>
+            <a:ext cx="5180986" cy="584775"/>
+          </a:xfrm>
+          <a:prstGeom prst="rect">
+            <a:avLst/>
+          </a:prstGeom>
+          <a:noFill/>
+        </p:spPr>
+        <p:txBody>
+          <a:bodyPr wrap="square" rtlCol="0">
+            <a:spAutoFit/>
+          </a:bodyPr>
+          <a:lstStyle/>
+          <a:p>
+            <a:r>
+              <a:t>Preferred Payment Method</a:t>
+            </a:r>
+          </a:p>
+        </p:txBody>
+      </p:sp>
+      <p:sp>
+        <p:nvSpPr>
+          <p:cNvPr id="21" name="content4">
+            <a:extLst>
+              <a:ext uri="{FF2B5EF4-FFF2-40B4-BE49-F238E27FC236}">
+                <a16:creationId xmlns:a16="http://schemas.microsoft.com/office/drawing/2014/main" id="{CFBB8D88-C46B-4BFD-95E5-3CD2F79AB4A3}"/>
+              </a:ext>
+            </a:extLst>
+          </p:cNvPr>
+          <p:cNvSpPr txBox="1"/>
+          <p:nvPr/>
+        </p:nvSpPr>
+        <p:spPr>
+          <a:xfrm>
+            <a:off x="6374296" y="5537102"/>
+            <a:ext cx="5148396" cy="646331"/>
           </a:xfrm>
           <a:prstGeom prst="rect">
             <a:avLst/>
@@ -3953,7 +4121,41 @@
           <a:lstStyle/>
           <a:p>
             <a:r>
-              <a:t>Performance Metrics: Sales, Production, and Market Share Analysis</a:t>
+              <a:t>Over 43% of users favor UPI for its ease, speed, and security, driving a shift towards digital transactions and lowering transaction costs.</a:t>
+            </a:r>
+          </a:p>
+        </p:txBody>
+      </p:sp>
+      <p:sp>
+        <p:nvSpPr>
+          <p:cNvPr id="27" name="subtopic">
+            <a:extLst>
+              <a:ext uri="{FF2B5EF4-FFF2-40B4-BE49-F238E27FC236}">
+                <a16:creationId xmlns:a16="http://schemas.microsoft.com/office/drawing/2014/main" id="{1FC39E55-DAC2-4D18-8701-DF4E171179AC}"/>
+              </a:ext>
+            </a:extLst>
+          </p:cNvPr>
+          <p:cNvSpPr txBox="1"/>
+          <p:nvPr/>
+        </p:nvSpPr>
+        <p:spPr>
+          <a:xfrm>
+            <a:off x="168257" y="330442"/>
+            <a:ext cx="10563455" cy="646331"/>
+          </a:xfrm>
+          <a:prstGeom prst="rect">
+            <a:avLst/>
+          </a:prstGeom>
+          <a:noFill/>
+        </p:spPr>
+        <p:txBody>
+          <a:bodyPr wrap="square" rtlCol="0">
+            <a:spAutoFit/>
+          </a:bodyPr>
+          <a:lstStyle/>
+          <a:p>
+            <a:r>
+              <a:t>UPI's Impact on Financial Inclusion and Economic Growth</a:t>
             </a:r>
           </a:p>
         </p:txBody>
@@ -3981,7 +4183,7 @@
           <p:cNvPr id="2" name="content1">
             <a:extLst>
               <a:ext uri="{FF2B5EF4-FFF2-40B4-BE49-F238E27FC236}">
-                <a16:creationId xmlns:a16="http://schemas.microsoft.com/office/drawing/2014/main" id="{4CFE2BC8-54A5-407E-B141-B5EC04BD3417}"/>
+                <a16:creationId xmlns:a16="http://schemas.microsoft.com/office/drawing/2014/main" id="{54FB0FDB-46CC-42BE-A833-C89184E3471E}"/>
               </a:ext>
             </a:extLst>
           </p:cNvPr>
@@ -3990,8 +4192,8 @@
         </p:nvSpPr>
         <p:spPr>
           <a:xfrm>
-            <a:off x="382842" y="2321170"/>
-            <a:ext cx="8588880" cy="646331"/>
+            <a:off x="350251" y="3043533"/>
+            <a:ext cx="5713159" cy="646331"/>
           </a:xfrm>
           <a:prstGeom prst="rect">
             <a:avLst/>
@@ -4010,7 +4212,7 @@
           <a:lstStyle/>
           <a:p>
             <a:r>
-              <a:t>BYD employs a cost-plus pricing strategy, leveraging vertical integration to maintain competitive pricing and secure market share.</a:t>
+              <a:t>UPI encounters issues like technical glitches and outages, impacting transaction success; ongoing infrastructure improvements aim to enhance reliability.</a:t>
             </a:r>
           </a:p>
         </p:txBody>
@@ -4020,7 +4222,7 @@
           <p:cNvPr id="3" name="head1">
             <a:extLst>
               <a:ext uri="{FF2B5EF4-FFF2-40B4-BE49-F238E27FC236}">
-                <a16:creationId xmlns:a16="http://schemas.microsoft.com/office/drawing/2014/main" id="{AF43DD1A-697B-4E09-8F47-DB6EB5F90E42}"/>
+                <a16:creationId xmlns:a16="http://schemas.microsoft.com/office/drawing/2014/main" id="{18484F3A-33E9-4106-BBE3-C35CDE75E4F4}"/>
               </a:ext>
             </a:extLst>
           </p:cNvPr>
@@ -4029,8 +4231,8 @@
         </p:nvSpPr>
         <p:spPr>
           <a:xfrm>
-            <a:off x="382842" y="1659451"/>
-            <a:ext cx="8588880" cy="646331"/>
+            <a:off x="350251" y="2441330"/>
+            <a:ext cx="5745749" cy="584775"/>
           </a:xfrm>
           <a:prstGeom prst="rect">
             <a:avLst/>
@@ -4044,17 +4246,17 @@
           <a:lstStyle/>
           <a:p>
             <a:r>
-              <a:t>BYD's Cost-Plus Pricing</a:t>
-            </a:r>
-          </a:p>
-        </p:txBody>
-      </p:sp>
-      <p:sp>
-        <p:nvSpPr>
-          <p:cNvPr id="5" name="content2">
+              <a:t>Technical Challenges in UPI</a:t>
+            </a:r>
+          </a:p>
+        </p:txBody>
+      </p:sp>
+      <p:sp>
+        <p:nvSpPr>
+          <p:cNvPr id="4" name="content3">
             <a:extLst>
               <a:ext uri="{FF2B5EF4-FFF2-40B4-BE49-F238E27FC236}">
-                <a16:creationId xmlns:a16="http://schemas.microsoft.com/office/drawing/2014/main" id="{0114294D-3C82-4496-9578-DE3D20CA1765}"/>
+                <a16:creationId xmlns:a16="http://schemas.microsoft.com/office/drawing/2014/main" id="{7ED6F132-1EC3-4F89-ACC9-391787BE6AE2}"/>
               </a:ext>
             </a:extLst>
           </p:cNvPr>
@@ -4063,8 +4265,8 @@
         </p:nvSpPr>
         <p:spPr>
           <a:xfrm>
-            <a:off x="402712" y="3940580"/>
-            <a:ext cx="8569010" cy="646331"/>
+            <a:off x="415434" y="5525002"/>
+            <a:ext cx="5647975" cy="646331"/>
           </a:xfrm>
           <a:prstGeom prst="rect">
             <a:avLst/>
@@ -4083,17 +4285,17 @@
           <a:lstStyle/>
           <a:p>
             <a:r>
-              <a:t>Tesla utilizes a value-based pricing strategy, focusing on premium branding and software integration, which enhances perceived value but limits volume growth.</a:t>
-            </a:r>
-          </a:p>
-        </p:txBody>
-      </p:sp>
-      <p:sp>
-        <p:nvSpPr>
-          <p:cNvPr id="6" name="head2">
+              <a:t>Despite high awareness of UPI, a gap exists in active usage, particularly in rural regions; targeted campaigns and incentives are crucial for building consumer trust.</a:t>
+            </a:r>
+          </a:p>
+        </p:txBody>
+      </p:sp>
+      <p:sp>
+        <p:nvSpPr>
+          <p:cNvPr id="5" name="head3">
             <a:extLst>
               <a:ext uri="{FF2B5EF4-FFF2-40B4-BE49-F238E27FC236}">
-                <a16:creationId xmlns:a16="http://schemas.microsoft.com/office/drawing/2014/main" id="{EC54FAE9-D0C9-4E6D-BD92-BE588E00A0E5}"/>
+                <a16:creationId xmlns:a16="http://schemas.microsoft.com/office/drawing/2014/main" id="{1EC6BFD2-A54A-4CFB-BE32-CB35F7C65D66}"/>
               </a:ext>
             </a:extLst>
           </p:cNvPr>
@@ -4102,8 +4304,8 @@
         </p:nvSpPr>
         <p:spPr>
           <a:xfrm>
-            <a:off x="388238" y="3281321"/>
-            <a:ext cx="8583484" cy="646331"/>
+            <a:off x="382842" y="4952327"/>
+            <a:ext cx="5680567" cy="584775"/>
           </a:xfrm>
           <a:prstGeom prst="rect">
             <a:avLst/>
@@ -4117,17 +4319,17 @@
           <a:lstStyle/>
           <a:p>
             <a:r>
-              <a:t>Tesla's Value-Based Approach</a:t>
-            </a:r>
-          </a:p>
-        </p:txBody>
-      </p:sp>
-      <p:sp>
-        <p:nvSpPr>
-          <p:cNvPr id="7" name="content3">
+              <a:t>Need for Awareness Campaigns</a:t>
+            </a:r>
+          </a:p>
+        </p:txBody>
+      </p:sp>
+      <p:sp>
+        <p:nvSpPr>
+          <p:cNvPr id="6" name="content2">
             <a:extLst>
               <a:ext uri="{FF2B5EF4-FFF2-40B4-BE49-F238E27FC236}">
-                <a16:creationId xmlns:a16="http://schemas.microsoft.com/office/drawing/2014/main" id="{BAB09B8F-FCBE-446C-89AD-F3E542DDA470}"/>
+                <a16:creationId xmlns:a16="http://schemas.microsoft.com/office/drawing/2014/main" id="{228BCD66-C14B-42CD-A438-BC7AA99965CD}"/>
               </a:ext>
             </a:extLst>
           </p:cNvPr>
@@ -4136,8 +4338,8 @@
         </p:nvSpPr>
         <p:spPr>
           <a:xfrm>
-            <a:off x="382842" y="5566061"/>
-            <a:ext cx="8583484" cy="646331"/>
+            <a:off x="6374296" y="3043533"/>
+            <a:ext cx="5148396" cy="646331"/>
           </a:xfrm>
           <a:prstGeom prst="rect">
             <a:avLst/>
@@ -4156,17 +4358,17 @@
           <a:lstStyle/>
           <a:p>
             <a:r>
-              <a:t>The contrasting strategies lead to a price war, with BYD's low-cost approach causing margin compression and brand dilution, while Tesla's premium focus restricts market expansion.</a:t>
-            </a:r>
-          </a:p>
-        </p:txBody>
-      </p:sp>
-      <p:sp>
-        <p:nvSpPr>
-          <p:cNvPr id="8" name="head3">
+              <a:t>Limited digital literacy and smartphone access in rural India hinder UPI adoption, necessitating initiatives to improve technology access and financial education.</a:t>
+            </a:r>
+          </a:p>
+        </p:txBody>
+      </p:sp>
+      <p:sp>
+        <p:nvSpPr>
+          <p:cNvPr id="7" name="head2">
             <a:extLst>
               <a:ext uri="{FF2B5EF4-FFF2-40B4-BE49-F238E27FC236}">
-                <a16:creationId xmlns:a16="http://schemas.microsoft.com/office/drawing/2014/main" id="{7F46E3E4-B57E-4E3B-ABC9-C8472D45B500}"/>
+                <a16:creationId xmlns:a16="http://schemas.microsoft.com/office/drawing/2014/main" id="{CD5BF12C-71C8-4652-9154-19F255752D5D}"/>
               </a:ext>
             </a:extLst>
           </p:cNvPr>
@@ -4175,8 +4377,8 @@
         </p:nvSpPr>
         <p:spPr>
           <a:xfrm>
-            <a:off x="388238" y="4900731"/>
-            <a:ext cx="8588880" cy="646331"/>
+            <a:off x="6341705" y="2441330"/>
+            <a:ext cx="5180986" cy="584775"/>
           </a:xfrm>
           <a:prstGeom prst="rect">
             <a:avLst/>
@@ -4190,17 +4392,17 @@
           <a:lstStyle/>
           <a:p>
             <a:r>
-              <a:t>Market Impact of Pricing Strategies</a:t>
-            </a:r>
-          </a:p>
-        </p:txBody>
-      </p:sp>
-      <p:sp>
-        <p:nvSpPr>
-          <p:cNvPr id="4" name="subtopic">
+              <a:t>Digital Divide in Rural Areas</a:t>
+            </a:r>
+          </a:p>
+        </p:txBody>
+      </p:sp>
+      <p:sp>
+        <p:nvSpPr>
+          <p:cNvPr id="9" name="head4">
             <a:extLst>
               <a:ext uri="{FF2B5EF4-FFF2-40B4-BE49-F238E27FC236}">
-                <a16:creationId xmlns:a16="http://schemas.microsoft.com/office/drawing/2014/main" id="{216BD8E4-BE8C-48D9-AFBB-D6093A341E66}"/>
+                <a16:creationId xmlns:a16="http://schemas.microsoft.com/office/drawing/2014/main" id="{B5F1E050-5BFC-480A-9E92-7665641E2034}"/>
               </a:ext>
             </a:extLst>
           </p:cNvPr>
@@ -4209,8 +4411,42 @@
         </p:nvSpPr>
         <p:spPr>
           <a:xfrm>
-            <a:off x="382842" y="202185"/>
-            <a:ext cx="10863056" cy="646331"/>
+            <a:off x="6341705" y="4952327"/>
+            <a:ext cx="5180986" cy="584775"/>
+          </a:xfrm>
+          <a:prstGeom prst="rect">
+            <a:avLst/>
+          </a:prstGeom>
+          <a:noFill/>
+        </p:spPr>
+        <p:txBody>
+          <a:bodyPr wrap="square" rtlCol="0">
+            <a:spAutoFit/>
+          </a:bodyPr>
+          <a:lstStyle/>
+          <a:p>
+            <a:r>
+              <a:t>Enhancements with UPI 2.0</a:t>
+            </a:r>
+          </a:p>
+        </p:txBody>
+      </p:sp>
+      <p:sp>
+        <p:nvSpPr>
+          <p:cNvPr id="21" name="content4">
+            <a:extLst>
+              <a:ext uri="{FF2B5EF4-FFF2-40B4-BE49-F238E27FC236}">
+                <a16:creationId xmlns:a16="http://schemas.microsoft.com/office/drawing/2014/main" id="{CFBB8D88-C46B-4BFD-95E5-3CD2F79AB4A3}"/>
+              </a:ext>
+            </a:extLst>
+          </p:cNvPr>
+          <p:cNvSpPr txBox="1"/>
+          <p:nvPr/>
+        </p:nvSpPr>
+        <p:spPr>
+          <a:xfrm>
+            <a:off x="6374296" y="5537102"/>
+            <a:ext cx="5148396" cy="646331"/>
           </a:xfrm>
           <a:prstGeom prst="rect">
             <a:avLst/>
@@ -4229,7 +4465,41 @@
           <a:lstStyle/>
           <a:p>
             <a:r>
-              <a:t>Pricing Strategies: Cost Comparisons and Value Propositions</a:t>
+              <a:t>UPI 2.0 introduces features like overdraft facilities to improve user experience, but ongoing investments in technology and fraud management are vital for sustainability.</a:t>
+            </a:r>
+          </a:p>
+        </p:txBody>
+      </p:sp>
+      <p:sp>
+        <p:nvSpPr>
+          <p:cNvPr id="27" name="subtopic">
+            <a:extLst>
+              <a:ext uri="{FF2B5EF4-FFF2-40B4-BE49-F238E27FC236}">
+                <a16:creationId xmlns:a16="http://schemas.microsoft.com/office/drawing/2014/main" id="{1FC39E55-DAC2-4D18-8701-DF4E171179AC}"/>
+              </a:ext>
+            </a:extLst>
+          </p:cNvPr>
+          <p:cNvSpPr txBox="1"/>
+          <p:nvPr/>
+        </p:nvSpPr>
+        <p:spPr>
+          <a:xfrm>
+            <a:off x="168257" y="330442"/>
+            <a:ext cx="10563455" cy="646331"/>
+          </a:xfrm>
+          <a:prstGeom prst="rect">
+            <a:avLst/>
+          </a:prstGeom>
+          <a:noFill/>
+        </p:spPr>
+        <p:txBody>
+          <a:bodyPr wrap="square" rtlCol="0">
+            <a:spAutoFit/>
+          </a:bodyPr>
+          <a:lstStyle/>
+          <a:p>
+            <a:r>
+              <a:t>Challenges and Solutions in UPI's Implementation and Adoption</a:t>
             </a:r>
           </a:p>
         </p:txBody>
@@ -4257,7 +4527,7 @@
           <p:cNvPr id="2" name="content1">
             <a:extLst>
               <a:ext uri="{FF2B5EF4-FFF2-40B4-BE49-F238E27FC236}">
-                <a16:creationId xmlns:a16="http://schemas.microsoft.com/office/drawing/2014/main" id="{4CFE2BC8-54A5-407E-B141-B5EC04BD3417}"/>
+                <a16:creationId xmlns:a16="http://schemas.microsoft.com/office/drawing/2014/main" id="{54FB0FDB-46CC-42BE-A833-C89184E3471E}"/>
               </a:ext>
             </a:extLst>
           </p:cNvPr>
@@ -4266,8 +4536,8 @@
         </p:nvSpPr>
         <p:spPr>
           <a:xfrm>
-            <a:off x="382842" y="2321170"/>
-            <a:ext cx="8588880" cy="646331"/>
+            <a:off x="350251" y="3043533"/>
+            <a:ext cx="5713159" cy="646331"/>
           </a:xfrm>
           <a:prstGeom prst="rect">
             <a:avLst/>
@@ -4286,7 +4556,7 @@
           <a:lstStyle/>
           <a:p>
             <a:r>
-              <a:t>Tesla's brand loyalty has decreased to 52.1% in 2023, down from approximately 67% in 2022, indicating a shift in consumer preferences.</a:t>
+              <a:t>UPI aims to launch in over 20 countries by March 2029, enhancing cross-border remittances and international trade efficiency.</a:t>
             </a:r>
           </a:p>
         </p:txBody>
@@ -4296,7 +4566,7 @@
           <p:cNvPr id="3" name="head1">
             <a:extLst>
               <a:ext uri="{FF2B5EF4-FFF2-40B4-BE49-F238E27FC236}">
-                <a16:creationId xmlns:a16="http://schemas.microsoft.com/office/drawing/2014/main" id="{AF43DD1A-697B-4E09-8F47-DB6EB5F90E42}"/>
+                <a16:creationId xmlns:a16="http://schemas.microsoft.com/office/drawing/2014/main" id="{18484F3A-33E9-4106-BBE3-C35CDE75E4F4}"/>
               </a:ext>
             </a:extLst>
           </p:cNvPr>
@@ -4305,8 +4575,8 @@
         </p:nvSpPr>
         <p:spPr>
           <a:xfrm>
-            <a:off x="382842" y="1659451"/>
-            <a:ext cx="8588880" cy="646331"/>
+            <a:off x="350251" y="2441330"/>
+            <a:ext cx="5745749" cy="584775"/>
           </a:xfrm>
           <a:prstGeom prst="rect">
             <a:avLst/>
@@ -4320,17 +4590,17 @@
           <a:lstStyle/>
           <a:p>
             <a:r>
-              <a:t>Tesla Brand Loyalty Decline</a:t>
-            </a:r>
-          </a:p>
-        </p:txBody>
-      </p:sp>
-      <p:sp>
-        <p:nvSpPr>
-          <p:cNvPr id="5" name="content2">
+              <a:t>Global Expansion Plans</a:t>
+            </a:r>
+          </a:p>
+        </p:txBody>
+      </p:sp>
+      <p:sp>
+        <p:nvSpPr>
+          <p:cNvPr id="4" name="content3">
             <a:extLst>
               <a:ext uri="{FF2B5EF4-FFF2-40B4-BE49-F238E27FC236}">
-                <a16:creationId xmlns:a16="http://schemas.microsoft.com/office/drawing/2014/main" id="{0114294D-3C82-4496-9578-DE3D20CA1765}"/>
+                <a16:creationId xmlns:a16="http://schemas.microsoft.com/office/drawing/2014/main" id="{7ED6F132-1EC3-4F89-ACC9-391787BE6AE2}"/>
               </a:ext>
             </a:extLst>
           </p:cNvPr>
@@ -4339,8 +4609,8 @@
         </p:nvSpPr>
         <p:spPr>
           <a:xfrm>
-            <a:off x="402712" y="3940580"/>
-            <a:ext cx="8569010" cy="646331"/>
+            <a:off x="415434" y="5525002"/>
+            <a:ext cx="5647975" cy="646331"/>
           </a:xfrm>
           <a:prstGeom prst="rect">
             <a:avLst/>
@@ -4359,17 +4629,17 @@
           <a:lstStyle/>
           <a:p>
             <a:r>
-              <a:t>Other EV brands have seen an increase in fuel-type loyalty to 46.4%, suggesting that consumers are increasingly committed to electric vehicles beyond Tesla.</a:t>
-            </a:r>
-          </a:p>
-        </p:txBody>
-      </p:sp>
-      <p:sp>
-        <p:nvSpPr>
-          <p:cNvPr id="6" name="head2">
+              <a:t>In October 2024, UPI achieved 16.58 billion transactions in a month, marking a 45% increase year-on-year due to improved banking integration.</a:t>
+            </a:r>
+          </a:p>
+        </p:txBody>
+      </p:sp>
+      <p:sp>
+        <p:nvSpPr>
+          <p:cNvPr id="5" name="head3">
             <a:extLst>
               <a:ext uri="{FF2B5EF4-FFF2-40B4-BE49-F238E27FC236}">
-                <a16:creationId xmlns:a16="http://schemas.microsoft.com/office/drawing/2014/main" id="{EC54FAE9-D0C9-4E6D-BD92-BE588E00A0E5}"/>
+                <a16:creationId xmlns:a16="http://schemas.microsoft.com/office/drawing/2014/main" id="{1EC6BFD2-A54A-4CFB-BE32-CB35F7C65D66}"/>
               </a:ext>
             </a:extLst>
           </p:cNvPr>
@@ -4378,8 +4648,8 @@
         </p:nvSpPr>
         <p:spPr>
           <a:xfrm>
-            <a:off x="388238" y="3281321"/>
-            <a:ext cx="8583484" cy="646331"/>
+            <a:off x="382842" y="4952327"/>
+            <a:ext cx="5680567" cy="584775"/>
           </a:xfrm>
           <a:prstGeom prst="rect">
             <a:avLst/>
@@ -4393,17 +4663,17 @@
           <a:lstStyle/>
           <a:p>
             <a:r>
-              <a:t>Increased EV Commitment</a:t>
-            </a:r>
-          </a:p>
-        </p:txBody>
-      </p:sp>
-      <p:sp>
-        <p:nvSpPr>
-          <p:cNvPr id="7" name="content3">
+              <a:t>Record Transaction Growth</a:t>
+            </a:r>
+          </a:p>
+        </p:txBody>
+      </p:sp>
+      <p:sp>
+        <p:nvSpPr>
+          <p:cNvPr id="6" name="content2">
             <a:extLst>
               <a:ext uri="{FF2B5EF4-FFF2-40B4-BE49-F238E27FC236}">
-                <a16:creationId xmlns:a16="http://schemas.microsoft.com/office/drawing/2014/main" id="{BAB09B8F-FCBE-446C-89AD-F3E542DDA470}"/>
+                <a16:creationId xmlns:a16="http://schemas.microsoft.com/office/drawing/2014/main" id="{228BCD66-C14B-42CD-A438-BC7AA99965CD}"/>
               </a:ext>
             </a:extLst>
           </p:cNvPr>
@@ -4412,8 +4682,8 @@
         </p:nvSpPr>
         <p:spPr>
           <a:xfrm>
-            <a:off x="382842" y="5566061"/>
-            <a:ext cx="8583484" cy="646331"/>
+            <a:off x="6374296" y="3043533"/>
+            <a:ext cx="5148396" cy="646331"/>
           </a:xfrm>
           <a:prstGeom prst="rect">
             <a:avLst/>
@@ -4432,17 +4702,17 @@
           <a:lstStyle/>
           <a:p>
             <a:r>
-              <a:t>Tesla owners are not switching to lower-priced vehicles; instead, they are moving to comparable or higher-priced models, particularly in the $75,000–$100,000 range.</a:t>
-            </a:r>
-          </a:p>
-        </p:txBody>
-      </p:sp>
-      <p:sp>
-        <p:nvSpPr>
-          <p:cNvPr id="8" name="head3">
+              <a:t>New UPI Circle allows users to delegate payment tasks to trusted contacts, while UPI Vouchers enable easy transfer of prepaid vouchers.</a:t>
+            </a:r>
+          </a:p>
+        </p:txBody>
+      </p:sp>
+      <p:sp>
+        <p:nvSpPr>
+          <p:cNvPr id="7" name="head2">
             <a:extLst>
               <a:ext uri="{FF2B5EF4-FFF2-40B4-BE49-F238E27FC236}">
-                <a16:creationId xmlns:a16="http://schemas.microsoft.com/office/drawing/2014/main" id="{7F46E3E4-B57E-4E3B-ABC9-C8472D45B500}"/>
+                <a16:creationId xmlns:a16="http://schemas.microsoft.com/office/drawing/2014/main" id="{CD5BF12C-71C8-4652-9154-19F255752D5D}"/>
               </a:ext>
             </a:extLst>
           </p:cNvPr>
@@ -4451,8 +4721,8 @@
         </p:nvSpPr>
         <p:spPr>
           <a:xfrm>
-            <a:off x="388238" y="4900731"/>
-            <a:ext cx="8588880" cy="646331"/>
+            <a:off x="6341705" y="2441330"/>
+            <a:ext cx="5180986" cy="584775"/>
           </a:xfrm>
           <a:prstGeom prst="rect">
             <a:avLst/>
@@ -4466,17 +4736,17 @@
           <a:lstStyle/>
           <a:p>
             <a:r>
-              <a:t>Defections to Premium Models</a:t>
-            </a:r>
-          </a:p>
-        </p:txBody>
-      </p:sp>
-      <p:sp>
-        <p:nvSpPr>
-          <p:cNvPr id="4" name="subtopic">
+              <a:t>Innovative Features</a:t>
+            </a:r>
+          </a:p>
+        </p:txBody>
+      </p:sp>
+      <p:sp>
+        <p:nvSpPr>
+          <p:cNvPr id="9" name="head4">
             <a:extLst>
               <a:ext uri="{FF2B5EF4-FFF2-40B4-BE49-F238E27FC236}">
-                <a16:creationId xmlns:a16="http://schemas.microsoft.com/office/drawing/2014/main" id="{216BD8E4-BE8C-48D9-AFBB-D6093A341E66}"/>
+                <a16:creationId xmlns:a16="http://schemas.microsoft.com/office/drawing/2014/main" id="{B5F1E050-5BFC-480A-9E92-7665641E2034}"/>
               </a:ext>
             </a:extLst>
           </p:cNvPr>
@@ -4485,8 +4755,42 @@
         </p:nvSpPr>
         <p:spPr>
           <a:xfrm>
-            <a:off x="382842" y="202185"/>
-            <a:ext cx="10863056" cy="646331"/>
+            <a:off x="6341705" y="4952327"/>
+            <a:ext cx="5180986" cy="584775"/>
+          </a:xfrm>
+          <a:prstGeom prst="rect">
+            <a:avLst/>
+          </a:prstGeom>
+          <a:noFill/>
+        </p:spPr>
+        <p:txBody>
+          <a:bodyPr wrap="square" rtlCol="0">
+            <a:spAutoFit/>
+          </a:bodyPr>
+          <a:lstStyle/>
+          <a:p>
+            <a:r>
+              <a:t>International Adoption</a:t>
+            </a:r>
+          </a:p>
+        </p:txBody>
+      </p:sp>
+      <p:sp>
+        <p:nvSpPr>
+          <p:cNvPr id="21" name="content4">
+            <a:extLst>
+              <a:ext uri="{FF2B5EF4-FFF2-40B4-BE49-F238E27FC236}">
+                <a16:creationId xmlns:a16="http://schemas.microsoft.com/office/drawing/2014/main" id="{CFBB8D88-C46B-4BFD-95E5-3CD2F79AB4A3}"/>
+              </a:ext>
+            </a:extLst>
+          </p:cNvPr>
+          <p:cNvSpPr txBox="1"/>
+          <p:nvPr/>
+        </p:nvSpPr>
+        <p:spPr>
+          <a:xfrm>
+            <a:off x="6374296" y="5537102"/>
+            <a:ext cx="5148396" cy="646331"/>
           </a:xfrm>
           <a:prstGeom prst="rect">
             <a:avLst/>
@@ -4505,7 +4809,41 @@
           <a:lstStyle/>
           <a:p>
             <a:r>
-              <a:t>Consumer Preferences: Brand Loyalty and Market Perception</a:t>
+              <a:t>UPI is already accepted in countries like the UAE and Singapore, with recent expansions into France and Sri Lanka, showcasing its global potential.</a:t>
+            </a:r>
+          </a:p>
+        </p:txBody>
+      </p:sp>
+      <p:sp>
+        <p:nvSpPr>
+          <p:cNvPr id="27" name="subtopic">
+            <a:extLst>
+              <a:ext uri="{FF2B5EF4-FFF2-40B4-BE49-F238E27FC236}">
+                <a16:creationId xmlns:a16="http://schemas.microsoft.com/office/drawing/2014/main" id="{1FC39E55-DAC2-4D18-8701-DF4E171179AC}"/>
+              </a:ext>
+            </a:extLst>
+          </p:cNvPr>
+          <p:cNvSpPr txBox="1"/>
+          <p:nvPr/>
+        </p:nvSpPr>
+        <p:spPr>
+          <a:xfrm>
+            <a:off x="168257" y="330442"/>
+            <a:ext cx="10563455" cy="646331"/>
+          </a:xfrm>
+          <a:prstGeom prst="rect">
+            <a:avLst/>
+          </a:prstGeom>
+          <a:noFill/>
+        </p:spPr>
+        <p:txBody>
+          <a:bodyPr wrap="square" rtlCol="0">
+            <a:spAutoFit/>
+          </a:bodyPr>
+          <a:lstStyle/>
+          <a:p>
+            <a:r>
+              <a:t>The Future of UPI: Global Expansion and Technological Advancements</a:t>
             </a:r>
           </a:p>
         </p:txBody>
@@ -4530,558 +4868,6 @@
       <p:grpSpPr/>
       <p:sp>
         <p:nvSpPr>
-          <p:cNvPr id="2" name="content1">
-            <a:extLst>
-              <a:ext uri="{FF2B5EF4-FFF2-40B4-BE49-F238E27FC236}">
-                <a16:creationId xmlns:a16="http://schemas.microsoft.com/office/drawing/2014/main" id="{4CFE2BC8-54A5-407E-B141-B5EC04BD3417}"/>
-              </a:ext>
-            </a:extLst>
-          </p:cNvPr>
-          <p:cNvSpPr txBox="1"/>
-          <p:nvPr/>
-        </p:nvSpPr>
-        <p:spPr>
-          <a:xfrm>
-            <a:off x="382842" y="2321170"/>
-            <a:ext cx="8588880" cy="646331"/>
-          </a:xfrm>
-          <a:prstGeom prst="rect">
-            <a:avLst/>
-          </a:prstGeom>
-          <a:noFill/>
-          <a:ln>
-            <a:solidFill>
-              <a:schemeClr val="bg1"/>
-            </a:solidFill>
-          </a:ln>
-        </p:spPr>
-        <p:txBody>
-          <a:bodyPr wrap="square" rtlCol="0">
-            <a:spAutoFit/>
-          </a:bodyPr>
-          <a:lstStyle/>
-          <a:p>
-            <a:r>
-              <a:t>Tesla is contesting the EU's tariffs on Chinese-made EVs, which could significantly impact global trade policies.</a:t>
-            </a:r>
-          </a:p>
-        </p:txBody>
-      </p:sp>
-      <p:sp>
-        <p:nvSpPr>
-          <p:cNvPr id="3" name="head1">
-            <a:extLst>
-              <a:ext uri="{FF2B5EF4-FFF2-40B4-BE49-F238E27FC236}">
-                <a16:creationId xmlns:a16="http://schemas.microsoft.com/office/drawing/2014/main" id="{AF43DD1A-697B-4E09-8F47-DB6EB5F90E42}"/>
-              </a:ext>
-            </a:extLst>
-          </p:cNvPr>
-          <p:cNvSpPr txBox="1"/>
-          <p:nvPr/>
-        </p:nvSpPr>
-        <p:spPr>
-          <a:xfrm>
-            <a:off x="382842" y="1659451"/>
-            <a:ext cx="8588880" cy="646331"/>
-          </a:xfrm>
-          <a:prstGeom prst="rect">
-            <a:avLst/>
-          </a:prstGeom>
-          <a:noFill/>
-        </p:spPr>
-        <p:txBody>
-          <a:bodyPr wrap="square" rtlCol="0">
-            <a:spAutoFit/>
-          </a:bodyPr>
-          <a:lstStyle/>
-          <a:p>
-            <a:r>
-              <a:t>Tesla's Legal Challenge</a:t>
-            </a:r>
-          </a:p>
-        </p:txBody>
-      </p:sp>
-      <p:sp>
-        <p:nvSpPr>
-          <p:cNvPr id="5" name="content2">
-            <a:extLst>
-              <a:ext uri="{FF2B5EF4-FFF2-40B4-BE49-F238E27FC236}">
-                <a16:creationId xmlns:a16="http://schemas.microsoft.com/office/drawing/2014/main" id="{0114294D-3C82-4496-9578-DE3D20CA1765}"/>
-              </a:ext>
-            </a:extLst>
-          </p:cNvPr>
-          <p:cNvSpPr txBox="1"/>
-          <p:nvPr/>
-        </p:nvSpPr>
-        <p:spPr>
-          <a:xfrm>
-            <a:off x="402712" y="3940580"/>
-            <a:ext cx="8569010" cy="646331"/>
-          </a:xfrm>
-          <a:prstGeom prst="rect">
-            <a:avLst/>
-          </a:prstGeom>
-          <a:noFill/>
-          <a:ln>
-            <a:solidFill>
-              <a:schemeClr val="bg1"/>
-            </a:solidFill>
-          </a:ln>
-        </p:spPr>
-        <p:txBody>
-          <a:bodyPr wrap="square" rtlCol="0">
-            <a:spAutoFit/>
-          </a:bodyPr>
-          <a:lstStyle/>
-          <a:p>
-            <a:r>
-              <a:t>Major automotive manufacturers, including BYD, are joining Tesla in challenging these tariffs, citing restrictions on free trade.</a:t>
-            </a:r>
-          </a:p>
-        </p:txBody>
-      </p:sp>
-      <p:sp>
-        <p:nvSpPr>
-          <p:cNvPr id="6" name="head2">
-            <a:extLst>
-              <a:ext uri="{FF2B5EF4-FFF2-40B4-BE49-F238E27FC236}">
-                <a16:creationId xmlns:a16="http://schemas.microsoft.com/office/drawing/2014/main" id="{EC54FAE9-D0C9-4E6D-BD92-BE588E00A0E5}"/>
-              </a:ext>
-            </a:extLst>
-          </p:cNvPr>
-          <p:cNvSpPr txBox="1"/>
-          <p:nvPr/>
-        </p:nvSpPr>
-        <p:spPr>
-          <a:xfrm>
-            <a:off x="388238" y="3281321"/>
-            <a:ext cx="8583484" cy="646331"/>
-          </a:xfrm>
-          <a:prstGeom prst="rect">
-            <a:avLst/>
-          </a:prstGeom>
-          <a:noFill/>
-        </p:spPr>
-        <p:txBody>
-          <a:bodyPr wrap="square" rtlCol="0">
-            <a:spAutoFit/>
-          </a:bodyPr>
-          <a:lstStyle/>
-          <a:p>
-            <a:r>
-              <a:t>Industry-Wide Opposition</a:t>
-            </a:r>
-          </a:p>
-        </p:txBody>
-      </p:sp>
-      <p:sp>
-        <p:nvSpPr>
-          <p:cNvPr id="7" name="content3">
-            <a:extLst>
-              <a:ext uri="{FF2B5EF4-FFF2-40B4-BE49-F238E27FC236}">
-                <a16:creationId xmlns:a16="http://schemas.microsoft.com/office/drawing/2014/main" id="{BAB09B8F-FCBE-446C-89AD-F3E542DDA470}"/>
-              </a:ext>
-            </a:extLst>
-          </p:cNvPr>
-          <p:cNvSpPr txBox="1"/>
-          <p:nvPr/>
-        </p:nvSpPr>
-        <p:spPr>
-          <a:xfrm>
-            <a:off x="382842" y="5566061"/>
-            <a:ext cx="8583484" cy="646331"/>
-          </a:xfrm>
-          <a:prstGeom prst="rect">
-            <a:avLst/>
-          </a:prstGeom>
-          <a:noFill/>
-          <a:ln>
-            <a:solidFill>
-              <a:schemeClr val="bg1"/>
-            </a:solidFill>
-          </a:ln>
-        </p:spPr>
-        <p:txBody>
-          <a:bodyPr wrap="square" rtlCol="0">
-            <a:spAutoFit/>
-          </a:bodyPr>
-          <a:lstStyle/>
-          <a:p>
-            <a:r>
-              <a:t>The outcome of these legal battles may hinder the global supply chain for EV production, affecting sustainability efforts.</a:t>
-            </a:r>
-          </a:p>
-        </p:txBody>
-      </p:sp>
-      <p:sp>
-        <p:nvSpPr>
-          <p:cNvPr id="8" name="head3">
-            <a:extLst>
-              <a:ext uri="{FF2B5EF4-FFF2-40B4-BE49-F238E27FC236}">
-                <a16:creationId xmlns:a16="http://schemas.microsoft.com/office/drawing/2014/main" id="{7F46E3E4-B57E-4E3B-ABC9-C8472D45B500}"/>
-              </a:ext>
-            </a:extLst>
-          </p:cNvPr>
-          <p:cNvSpPr txBox="1"/>
-          <p:nvPr/>
-        </p:nvSpPr>
-        <p:spPr>
-          <a:xfrm>
-            <a:off x="388238" y="4900731"/>
-            <a:ext cx="8588880" cy="646331"/>
-          </a:xfrm>
-          <a:prstGeom prst="rect">
-            <a:avLst/>
-          </a:prstGeom>
-          <a:noFill/>
-        </p:spPr>
-        <p:txBody>
-          <a:bodyPr wrap="square" rtlCol="0">
-            <a:spAutoFit/>
-          </a:bodyPr>
-          <a:lstStyle/>
-          <a:p>
-            <a:r>
-              <a:t>Impact on Global Supply Chains</a:t>
-            </a:r>
-          </a:p>
-        </p:txBody>
-      </p:sp>
-      <p:sp>
-        <p:nvSpPr>
-          <p:cNvPr id="4" name="subtopic">
-            <a:extLst>
-              <a:ext uri="{FF2B5EF4-FFF2-40B4-BE49-F238E27FC236}">
-                <a16:creationId xmlns:a16="http://schemas.microsoft.com/office/drawing/2014/main" id="{216BD8E4-BE8C-48D9-AFBB-D6093A341E66}"/>
-              </a:ext>
-            </a:extLst>
-          </p:cNvPr>
-          <p:cNvSpPr txBox="1"/>
-          <p:nvPr/>
-        </p:nvSpPr>
-        <p:spPr>
-          <a:xfrm>
-            <a:off x="382842" y="202185"/>
-            <a:ext cx="10863056" cy="646331"/>
-          </a:xfrm>
-          <a:prstGeom prst="rect">
-            <a:avLst/>
-          </a:prstGeom>
-          <a:noFill/>
-          <a:ln>
-            <a:solidFill>
-              <a:schemeClr val="bg1"/>
-            </a:solidFill>
-          </a:ln>
-        </p:spPr>
-        <p:txBody>
-          <a:bodyPr wrap="square" rtlCol="0">
-            <a:spAutoFit/>
-          </a:bodyPr>
-          <a:lstStyle/>
-          <a:p>
-            <a:r>
-              <a:t>Regulatory Challenges: Impact of Tariffs and Global Policies</a:t>
-            </a:r>
-          </a:p>
-        </p:txBody>
-      </p:sp>
-    </p:spTree>
-  </p:cSld>
-  <p:clrMapOvr>
-    <a:masterClrMapping/>
-  </p:clrMapOvr>
-</p:sld>
-</file>
-
-<file path=ppt/slides/slide8.xml><?xml version="1.0" encoding="utf-8"?>
-<p:sld xmlns:a="http://schemas.openxmlformats.org/drawingml/2006/main" xmlns:p="http://schemas.openxmlformats.org/presentationml/2006/main" xmlns:r="http://schemas.openxmlformats.org/officeDocument/2006/relationships">
-  <p:cSld>
-    <p:spTree>
-      <p:nvGrpSpPr>
-        <p:cNvPr id="1" name=""/>
-        <p:cNvGrpSpPr/>
-        <p:nvPr/>
-      </p:nvGrpSpPr>
-      <p:grpSpPr/>
-      <p:sp>
-        <p:nvSpPr>
-          <p:cNvPr id="2" name="content1">
-            <a:extLst>
-              <a:ext uri="{FF2B5EF4-FFF2-40B4-BE49-F238E27FC236}">
-                <a16:creationId xmlns:a16="http://schemas.microsoft.com/office/drawing/2014/main" id="{4CFE2BC8-54A5-407E-B141-B5EC04BD3417}"/>
-              </a:ext>
-            </a:extLst>
-          </p:cNvPr>
-          <p:cNvSpPr txBox="1"/>
-          <p:nvPr/>
-        </p:nvSpPr>
-        <p:spPr>
-          <a:xfrm>
-            <a:off x="382842" y="2321170"/>
-            <a:ext cx="8588880" cy="646331"/>
-          </a:xfrm>
-          <a:prstGeom prst="rect">
-            <a:avLst/>
-          </a:prstGeom>
-          <a:noFill/>
-          <a:ln>
-            <a:solidFill>
-              <a:schemeClr val="bg1"/>
-            </a:solidFill>
-          </a:ln>
-        </p:spPr>
-        <p:txBody>
-          <a:bodyPr wrap="square" rtlCol="0">
-            <a:spAutoFit/>
-          </a:bodyPr>
-          <a:lstStyle/>
-          <a:p>
-            <a:r>
-              <a:t>BYD is projected to surpass Tesla in battery electric vehicle sales in 2024, indicating a significant shift in market dynamics.</a:t>
-            </a:r>
-          </a:p>
-        </p:txBody>
-      </p:sp>
-      <p:sp>
-        <p:nvSpPr>
-          <p:cNvPr id="3" name="head1">
-            <a:extLst>
-              <a:ext uri="{FF2B5EF4-FFF2-40B4-BE49-F238E27FC236}">
-                <a16:creationId xmlns:a16="http://schemas.microsoft.com/office/drawing/2014/main" id="{AF43DD1A-697B-4E09-8F47-DB6EB5F90E42}"/>
-              </a:ext>
-            </a:extLst>
-          </p:cNvPr>
-          <p:cNvSpPr txBox="1"/>
-          <p:nvPr/>
-        </p:nvSpPr>
-        <p:spPr>
-          <a:xfrm>
-            <a:off x="382842" y="1659451"/>
-            <a:ext cx="8588880" cy="646331"/>
-          </a:xfrm>
-          <a:prstGeom prst="rect">
-            <a:avLst/>
-          </a:prstGeom>
-          <a:noFill/>
-        </p:spPr>
-        <p:txBody>
-          <a:bodyPr wrap="square" rtlCol="0">
-            <a:spAutoFit/>
-          </a:bodyPr>
-          <a:lstStyle/>
-          <a:p>
-            <a:r>
-              <a:t>BYD's Market Surge</a:t>
-            </a:r>
-          </a:p>
-        </p:txBody>
-      </p:sp>
-      <p:sp>
-        <p:nvSpPr>
-          <p:cNvPr id="5" name="content2">
-            <a:extLst>
-              <a:ext uri="{FF2B5EF4-FFF2-40B4-BE49-F238E27FC236}">
-                <a16:creationId xmlns:a16="http://schemas.microsoft.com/office/drawing/2014/main" id="{0114294D-3C82-4496-9578-DE3D20CA1765}"/>
-              </a:ext>
-            </a:extLst>
-          </p:cNvPr>
-          <p:cNvSpPr txBox="1"/>
-          <p:nvPr/>
-        </p:nvSpPr>
-        <p:spPr>
-          <a:xfrm>
-            <a:off x="402712" y="3940580"/>
-            <a:ext cx="8569010" cy="646331"/>
-          </a:xfrm>
-          <a:prstGeom prst="rect">
-            <a:avLst/>
-          </a:prstGeom>
-          <a:noFill/>
-          <a:ln>
-            <a:solidFill>
-              <a:schemeClr val="bg1"/>
-            </a:solidFill>
-          </a:ln>
-        </p:spPr>
-        <p:txBody>
-          <a:bodyPr wrap="square" rtlCol="0">
-            <a:spAutoFit/>
-          </a:bodyPr>
-          <a:lstStyle/>
-          <a:p>
-            <a:r>
-              <a:t>Global battery electric vehicle sales are expected to reach 10 million in 2024, driven by declining internal combustion engine vehicles.</a:t>
-            </a:r>
-          </a:p>
-        </p:txBody>
-      </p:sp>
-      <p:sp>
-        <p:nvSpPr>
-          <p:cNvPr id="6" name="head2">
-            <a:extLst>
-              <a:ext uri="{FF2B5EF4-FFF2-40B4-BE49-F238E27FC236}">
-                <a16:creationId xmlns:a16="http://schemas.microsoft.com/office/drawing/2014/main" id="{EC54FAE9-D0C9-4E6D-BD92-BE588E00A0E5}"/>
-              </a:ext>
-            </a:extLst>
-          </p:cNvPr>
-          <p:cNvSpPr txBox="1"/>
-          <p:nvPr/>
-        </p:nvSpPr>
-        <p:spPr>
-          <a:xfrm>
-            <a:off x="388238" y="3281321"/>
-            <a:ext cx="8583484" cy="646331"/>
-          </a:xfrm>
-          <a:prstGeom prst="rect">
-            <a:avLst/>
-          </a:prstGeom>
-          <a:noFill/>
-        </p:spPr>
-        <p:txBody>
-          <a:bodyPr wrap="square" rtlCol="0">
-            <a:spAutoFit/>
-          </a:bodyPr>
-          <a:lstStyle/>
-          <a:p>
-            <a:r>
-              <a:t>Global BEV Growth</a:t>
-            </a:r>
-          </a:p>
-        </p:txBody>
-      </p:sp>
-      <p:sp>
-        <p:nvSpPr>
-          <p:cNvPr id="7" name="content3">
-            <a:extLst>
-              <a:ext uri="{FF2B5EF4-FFF2-40B4-BE49-F238E27FC236}">
-                <a16:creationId xmlns:a16="http://schemas.microsoft.com/office/drawing/2014/main" id="{BAB09B8F-FCBE-446C-89AD-F3E542DDA470}"/>
-              </a:ext>
-            </a:extLst>
-          </p:cNvPr>
-          <p:cNvSpPr txBox="1"/>
-          <p:nvPr/>
-        </p:nvSpPr>
-        <p:spPr>
-          <a:xfrm>
-            <a:off x="382842" y="5566061"/>
-            <a:ext cx="8583484" cy="646331"/>
-          </a:xfrm>
-          <a:prstGeom prst="rect">
-            <a:avLst/>
-          </a:prstGeom>
-          <a:noFill/>
-          <a:ln>
-            <a:solidFill>
-              <a:schemeClr val="bg1"/>
-            </a:solidFill>
-          </a:ln>
-        </p:spPr>
-        <p:txBody>
-          <a:bodyPr wrap="square" rtlCol="0">
-            <a:spAutoFit/>
-          </a:bodyPr>
-          <a:lstStyle/>
-          <a:p>
-            <a:r>
-              <a:t>Tariffs may push Chinese automakers like BYD towards emerging markets, including the Middle East, Africa, and Southeast Asia, for growth opportunities.</a:t>
-            </a:r>
-          </a:p>
-        </p:txBody>
-      </p:sp>
-      <p:sp>
-        <p:nvSpPr>
-          <p:cNvPr id="8" name="head3">
-            <a:extLst>
-              <a:ext uri="{FF2B5EF4-FFF2-40B4-BE49-F238E27FC236}">
-                <a16:creationId xmlns:a16="http://schemas.microsoft.com/office/drawing/2014/main" id="{7F46E3E4-B57E-4E3B-ABC9-C8472D45B500}"/>
-              </a:ext>
-            </a:extLst>
-          </p:cNvPr>
-          <p:cNvSpPr txBox="1"/>
-          <p:nvPr/>
-        </p:nvSpPr>
-        <p:spPr>
-          <a:xfrm>
-            <a:off x="388238" y="4900731"/>
-            <a:ext cx="8588880" cy="646331"/>
-          </a:xfrm>
-          <a:prstGeom prst="rect">
-            <a:avLst/>
-          </a:prstGeom>
-          <a:noFill/>
-        </p:spPr>
-        <p:txBody>
-          <a:bodyPr wrap="square" rtlCol="0">
-            <a:spAutoFit/>
-          </a:bodyPr>
-          <a:lstStyle/>
-          <a:p>
-            <a:r>
-              <a:t>Emerging Market Focus</a:t>
-            </a:r>
-          </a:p>
-        </p:txBody>
-      </p:sp>
-      <p:sp>
-        <p:nvSpPr>
-          <p:cNvPr id="4" name="subtopic">
-            <a:extLst>
-              <a:ext uri="{FF2B5EF4-FFF2-40B4-BE49-F238E27FC236}">
-                <a16:creationId xmlns:a16="http://schemas.microsoft.com/office/drawing/2014/main" id="{216BD8E4-BE8C-48D9-AFBB-D6093A341E66}"/>
-              </a:ext>
-            </a:extLst>
-          </p:cNvPr>
-          <p:cNvSpPr txBox="1"/>
-          <p:nvPr/>
-        </p:nvSpPr>
-        <p:spPr>
-          <a:xfrm>
-            <a:off x="382842" y="202185"/>
-            <a:ext cx="10863056" cy="646331"/>
-          </a:xfrm>
-          <a:prstGeom prst="rect">
-            <a:avLst/>
-          </a:prstGeom>
-          <a:noFill/>
-          <a:ln>
-            <a:solidFill>
-              <a:schemeClr val="bg1"/>
-            </a:solidFill>
-          </a:ln>
-        </p:spPr>
-        <p:txBody>
-          <a:bodyPr wrap="square" rtlCol="0">
-            <a:spAutoFit/>
-          </a:bodyPr>
-          <a:lstStyle/>
-          <a:p>
-            <a:r>
-              <a:t>Future Outlook: Predictions for Growth and Market Dynamics</a:t>
-            </a:r>
-          </a:p>
-        </p:txBody>
-      </p:sp>
-    </p:spTree>
-  </p:cSld>
-  <p:clrMapOvr>
-    <a:masterClrMapping/>
-  </p:clrMapOvr>
-</p:sld>
-</file>
-
-<file path=ppt/slides/slide9.xml><?xml version="1.0" encoding="utf-8"?>
-<p:sld xmlns:a="http://schemas.openxmlformats.org/drawingml/2006/main" xmlns:p="http://schemas.openxmlformats.org/presentationml/2006/main" xmlns:r="http://schemas.openxmlformats.org/officeDocument/2006/relationships">
-  <p:cSld>
-    <p:spTree>
-      <p:nvGrpSpPr>
-        <p:cNvPr id="1" name=""/>
-        <p:cNvGrpSpPr/>
-        <p:nvPr/>
-      </p:nvGrpSpPr>
-      <p:grpSpPr/>
-      <p:sp>
-        <p:nvSpPr>
           <p:cNvPr id="3" name="ending">
             <a:extLst>
               <a:ext uri="{FF2B5EF4-FFF2-40B4-BE49-F238E27FC236}">
@@ -5109,7 +4895,7 @@
           <a:lstStyle/>
           <a:p>
             <a:r>
-              <a:t>In conclusion, the competition between Tesla and BYD is reshaping the electric vehicle landscape, with significant implications for the future of the industry.</a:t>
+              <a:t>The journey of UPI exemplifies the transformative power of digital payments in shaping India's financial landscape.</a:t>
             </a:r>
           </a:p>
         </p:txBody>

</xml_diff>

<commit_message>
prepare app for deployment
</commit_message>
<xml_diff>
--- a/final_output.pptx
+++ b/final_output.pptx
@@ -8,6 +8,7 @@
     <p:sldId id="256" r:id="rId7"/>
     <p:sldId id="257" r:id="rId8"/>
     <p:sldId id="258" r:id="rId9"/>
+    <p:sldId id="259" r:id="rId10"/>
   </p:sldIdLst>
   <p:sldSz cx="12192000" cy="6858000" type="screen4x3"/>
   <p:notesSz cx="6858000" cy="9144000"/>
@@ -3119,7 +3120,7 @@
           <a:lstStyle/>
           <a:p>
             <a:r>
-              <a:t>The Global Journey of Ramen</a:t>
+              <a:t>famous foods in USA</a:t>
             </a:r>
           </a:p>
         </p:txBody>
@@ -3176,7 +3177,7 @@
           <a:lstStyle/>
           <a:p>
             <a:r>
-              <a:t>Ramen traces its roots to China, where wheat noodles were enjoyed as early as the 3rd century AD, before being introduced to Japan by Chinese immigrants in the late 19th century.</a:t>
+              <a:t>The U.S. features iconic dishes like New England clam chowder and Kansas City barbecue, showcasing its diverse culinary heritage shaped by history and geography.</a:t>
             </a:r>
           </a:p>
         </p:txBody>
@@ -3210,7 +3211,7 @@
           <a:lstStyle/>
           <a:p>
             <a:r>
-              <a:t>Origins in China</a:t>
+              <a:t>Regional Culinary Icons</a:t>
             </a:r>
           </a:p>
         </p:txBody>
@@ -3249,7 +3250,7 @@
           <a:lstStyle/>
           <a:p>
             <a:r>
-              <a:t>Ramen has evolved with plant-based options, self-heating packaging, and gourmet flavors, while regional styles in Japan highlight local ingredients and inspire international fusion dishes.</a:t>
+              <a:t>American cuisine evolves through global integration, with Tex-Mex in the Southwest and Asian flavors in cities like San Francisco enriching the culinary landscape.</a:t>
             </a:r>
           </a:p>
         </p:txBody>
@@ -3283,7 +3284,7 @@
           <a:lstStyle/>
           <a:p>
             <a:r>
-              <a:t>Innovations and Variations</a:t>
+              <a:t>Global Influences on American Cuisine</a:t>
             </a:r>
           </a:p>
         </p:txBody>
@@ -3322,7 +3323,7 @@
           <a:lstStyle/>
           <a:p>
             <a:r>
-              <a:t>The ramen market is expected to reach $84.99 billion by 2030, growing at a CAGR of 7.9%, fueled by rising demand for premium, healthier options and online retail expansion.</a:t>
+              <a:t>Dishes such as Louisiana gumbo and New England lobster rolls celebrate local ingredients and reflect the cultural traditions of their regions.</a:t>
             </a:r>
           </a:p>
         </p:txBody>
@@ -3356,7 +3357,7 @@
           <a:lstStyle/>
           <a:p>
             <a:r>
-              <a:t>Global Market Growth</a:t>
+              <a:t>Distinct Regional Specialties</a:t>
             </a:r>
           </a:p>
         </p:txBody>
@@ -3390,7 +3391,7 @@
           <a:lstStyle/>
           <a:p>
             <a:r>
-              <a:t>Cultural Impact in Japan</a:t>
+              <a:t>Celebrating Food Festivals</a:t>
             </a:r>
           </a:p>
         </p:txBody>
@@ -3429,7 +3430,7 @@
           <a:lstStyle/>
           <a:p>
             <a:r>
-              <a:t>The 1980s ramen boom in Japan led to the rise of dedicated restaurants and museums, cementing ramen's status as a culinary staple and influencing global culinary trends.</a:t>
+              <a:t>Annual events like the National Shrimp Festival promote regional dishes, fostering community engagement and highlighting the significance of food in American culture.</a:t>
             </a:r>
           </a:p>
         </p:txBody>
@@ -3463,7 +3464,7 @@
           <a:lstStyle/>
           <a:p>
             <a:r>
-              <a:t>The Evolution of Ramen: From Traditional Roots to Global Phenomenon</a:t>
+              <a:t>Regional Icons: Exploring America's Culinary Diversity</a:t>
             </a:r>
           </a:p>
         </p:txBody>
@@ -3488,6 +3489,350 @@
       <p:grpSpPr/>
       <p:sp>
         <p:nvSpPr>
+          <p:cNvPr id="2" name="content1">
+            <a:extLst>
+              <a:ext uri="{FF2B5EF4-FFF2-40B4-BE49-F238E27FC236}">
+                <a16:creationId xmlns:a16="http://schemas.microsoft.com/office/drawing/2014/main" id="{54FB0FDB-46CC-42BE-A833-C89184E3471E}"/>
+              </a:ext>
+            </a:extLst>
+          </p:cNvPr>
+          <p:cNvSpPr txBox="1"/>
+          <p:nvPr/>
+        </p:nvSpPr>
+        <p:spPr>
+          <a:xfrm>
+            <a:off x="350251" y="3043533"/>
+            <a:ext cx="5713159" cy="646331"/>
+          </a:xfrm>
+          <a:prstGeom prst="rect">
+            <a:avLst/>
+          </a:prstGeom>
+          <a:noFill/>
+          <a:ln>
+            <a:solidFill>
+              <a:schemeClr val="bg1"/>
+            </a:solidFill>
+          </a:ln>
+        </p:spPr>
+        <p:txBody>
+          <a:bodyPr wrap="square" rtlCol="0">
+            <a:spAutoFit/>
+          </a:bodyPr>
+          <a:lstStyle/>
+          <a:p>
+            <a:r>
+              <a:t>Originating from Buffalo, New York, these spicy wings served with blue cheese dip are a sports bar staple, especially during the Super Bowl, reflecting America's love for bold flavors.</a:t>
+            </a:r>
+          </a:p>
+        </p:txBody>
+      </p:sp>
+      <p:sp>
+        <p:nvSpPr>
+          <p:cNvPr id="3" name="head1">
+            <a:extLst>
+              <a:ext uri="{FF2B5EF4-FFF2-40B4-BE49-F238E27FC236}">
+                <a16:creationId xmlns:a16="http://schemas.microsoft.com/office/drawing/2014/main" id="{18484F3A-33E9-4106-BBE3-C35CDE75E4F4}"/>
+              </a:ext>
+            </a:extLst>
+          </p:cNvPr>
+          <p:cNvSpPr txBox="1"/>
+          <p:nvPr/>
+        </p:nvSpPr>
+        <p:spPr>
+          <a:xfrm>
+            <a:off x="350251" y="2441330"/>
+            <a:ext cx="5745749" cy="584775"/>
+          </a:xfrm>
+          <a:prstGeom prst="rect">
+            <a:avLst/>
+          </a:prstGeom>
+          <a:noFill/>
+        </p:spPr>
+        <p:txBody>
+          <a:bodyPr wrap="square" rtlCol="0">
+            <a:spAutoFit/>
+          </a:bodyPr>
+          <a:lstStyle/>
+          <a:p>
+            <a:r>
+              <a:t>Buffalo Wings Delight</a:t>
+            </a:r>
+          </a:p>
+        </p:txBody>
+      </p:sp>
+      <p:sp>
+        <p:nvSpPr>
+          <p:cNvPr id="4" name="content3">
+            <a:extLst>
+              <a:ext uri="{FF2B5EF4-FFF2-40B4-BE49-F238E27FC236}">
+                <a16:creationId xmlns:a16="http://schemas.microsoft.com/office/drawing/2014/main" id="{7ED6F132-1EC3-4F89-ACC9-391787BE6AE2}"/>
+              </a:ext>
+            </a:extLst>
+          </p:cNvPr>
+          <p:cNvSpPr txBox="1"/>
+          <p:nvPr/>
+        </p:nvSpPr>
+        <p:spPr>
+          <a:xfrm>
+            <a:off x="415434" y="5525002"/>
+            <a:ext cx="5647975" cy="646331"/>
+          </a:xfrm>
+          <a:prstGeom prst="rect">
+            <a:avLst/>
+          </a:prstGeom>
+          <a:noFill/>
+          <a:ln>
+            <a:solidFill>
+              <a:schemeClr val="bg1"/>
+            </a:solidFill>
+          </a:ln>
+        </p:spPr>
+        <p:txBody>
+          <a:bodyPr wrap="square" rtlCol="0">
+            <a:spAutoFit/>
+          </a:bodyPr>
+          <a:lstStyle/>
+          <a:p>
+            <a:r>
+              <a:t>With over 50 billion hamburgers consumed annually, this iconic dish leads the list of popular American foods, highlighting its status as a beloved comfort food across the nation.</a:t>
+            </a:r>
+          </a:p>
+        </p:txBody>
+      </p:sp>
+      <p:sp>
+        <p:nvSpPr>
+          <p:cNvPr id="5" name="head3">
+            <a:extLst>
+              <a:ext uri="{FF2B5EF4-FFF2-40B4-BE49-F238E27FC236}">
+                <a16:creationId xmlns:a16="http://schemas.microsoft.com/office/drawing/2014/main" id="{1EC6BFD2-A54A-4CFB-BE32-CB35F7C65D66}"/>
+              </a:ext>
+            </a:extLst>
+          </p:cNvPr>
+          <p:cNvSpPr txBox="1"/>
+          <p:nvPr/>
+        </p:nvSpPr>
+        <p:spPr>
+          <a:xfrm>
+            <a:off x="382842" y="4952327"/>
+            <a:ext cx="5680567" cy="584775"/>
+          </a:xfrm>
+          <a:prstGeom prst="rect">
+            <a:avLst/>
+          </a:prstGeom>
+          <a:noFill/>
+        </p:spPr>
+        <p:txBody>
+          <a:bodyPr wrap="square" rtlCol="0">
+            <a:spAutoFit/>
+          </a:bodyPr>
+          <a:lstStyle/>
+          <a:p>
+            <a:r>
+              <a:t>America's Burger Obsession</a:t>
+            </a:r>
+          </a:p>
+        </p:txBody>
+      </p:sp>
+      <p:sp>
+        <p:nvSpPr>
+          <p:cNvPr id="6" name="content2">
+            <a:extLst>
+              <a:ext uri="{FF2B5EF4-FFF2-40B4-BE49-F238E27FC236}">
+                <a16:creationId xmlns:a16="http://schemas.microsoft.com/office/drawing/2014/main" id="{228BCD66-C14B-42CD-A438-BC7AA99965CD}"/>
+              </a:ext>
+            </a:extLst>
+          </p:cNvPr>
+          <p:cNvSpPr txBox="1"/>
+          <p:nvPr/>
+        </p:nvSpPr>
+        <p:spPr>
+          <a:xfrm>
+            <a:off x="6374296" y="3043533"/>
+            <a:ext cx="5148396" cy="646331"/>
+          </a:xfrm>
+          <a:prstGeom prst="rect">
+            <a:avLst/>
+          </a:prstGeom>
+          <a:noFill/>
+          <a:ln>
+            <a:solidFill>
+              <a:schemeClr val="bg1"/>
+            </a:solidFill>
+          </a:ln>
+        </p:spPr>
+        <p:txBody>
+          <a:bodyPr wrap="square" rtlCol="0">
+            <a:spAutoFit/>
+          </a:bodyPr>
+          <a:lstStyle/>
+          <a:p>
+            <a:r>
+              <a:t>Dishes like New England clam chowder, Louisiana gumbo, and Chicago deep-dish pizza showcase local ingredients and cultural heritage, making food travel a popular trend for authentic experiences.</a:t>
+            </a:r>
+          </a:p>
+        </p:txBody>
+      </p:sp>
+      <p:sp>
+        <p:nvSpPr>
+          <p:cNvPr id="7" name="head2">
+            <a:extLst>
+              <a:ext uri="{FF2B5EF4-FFF2-40B4-BE49-F238E27FC236}">
+                <a16:creationId xmlns:a16="http://schemas.microsoft.com/office/drawing/2014/main" id="{CD5BF12C-71C8-4652-9154-19F255752D5D}"/>
+              </a:ext>
+            </a:extLst>
+          </p:cNvPr>
+          <p:cNvSpPr txBox="1"/>
+          <p:nvPr/>
+        </p:nvSpPr>
+        <p:spPr>
+          <a:xfrm>
+            <a:off x="6341705" y="2441330"/>
+            <a:ext cx="5180986" cy="584775"/>
+          </a:xfrm>
+          <a:prstGeom prst="rect">
+            <a:avLst/>
+          </a:prstGeom>
+          <a:noFill/>
+        </p:spPr>
+        <p:txBody>
+          <a:bodyPr wrap="square" rtlCol="0">
+            <a:spAutoFit/>
+          </a:bodyPr>
+          <a:lstStyle/>
+          <a:p>
+            <a:r>
+              <a:t>Regional Culinary Treasures</a:t>
+            </a:r>
+          </a:p>
+        </p:txBody>
+      </p:sp>
+      <p:sp>
+        <p:nvSpPr>
+          <p:cNvPr id="9" name="head4">
+            <a:extLst>
+              <a:ext uri="{FF2B5EF4-FFF2-40B4-BE49-F238E27FC236}">
+                <a16:creationId xmlns:a16="http://schemas.microsoft.com/office/drawing/2014/main" id="{B5F1E050-5BFC-480A-9E92-7665641E2034}"/>
+              </a:ext>
+            </a:extLst>
+          </p:cNvPr>
+          <p:cNvSpPr txBox="1"/>
+          <p:nvPr/>
+        </p:nvSpPr>
+        <p:spPr>
+          <a:xfrm>
+            <a:off x="6341705" y="4952327"/>
+            <a:ext cx="5180986" cy="584775"/>
+          </a:xfrm>
+          <a:prstGeom prst="rect">
+            <a:avLst/>
+          </a:prstGeom>
+          <a:noFill/>
+        </p:spPr>
+        <p:txBody>
+          <a:bodyPr wrap="square" rtlCol="0">
+            <a:spAutoFit/>
+          </a:bodyPr>
+          <a:lstStyle/>
+          <a:p>
+            <a:r>
+              <a:t>Growing Food Travel Trend</a:t>
+            </a:r>
+          </a:p>
+        </p:txBody>
+      </p:sp>
+      <p:sp>
+        <p:nvSpPr>
+          <p:cNvPr id="21" name="content4">
+            <a:extLst>
+              <a:ext uri="{FF2B5EF4-FFF2-40B4-BE49-F238E27FC236}">
+                <a16:creationId xmlns:a16="http://schemas.microsoft.com/office/drawing/2014/main" id="{CFBB8D88-C46B-4BFD-95E5-3CD2F79AB4A3}"/>
+              </a:ext>
+            </a:extLst>
+          </p:cNvPr>
+          <p:cNvSpPr txBox="1"/>
+          <p:nvPr/>
+        </p:nvSpPr>
+        <p:spPr>
+          <a:xfrm>
+            <a:off x="6374296" y="5537102"/>
+            <a:ext cx="5148396" cy="646331"/>
+          </a:xfrm>
+          <a:prstGeom prst="rect">
+            <a:avLst/>
+          </a:prstGeom>
+          <a:noFill/>
+          <a:ln>
+            <a:solidFill>
+              <a:schemeClr val="bg1"/>
+            </a:solidFill>
+          </a:ln>
+        </p:spPr>
+        <p:txBody>
+          <a:bodyPr wrap="square" rtlCol="0">
+            <a:spAutoFit/>
+          </a:bodyPr>
+          <a:lstStyle/>
+          <a:p>
+            <a:r>
+              <a:t>Travelers are increasingly seeking regional specialties to connect with local culture, supported by a rise in restaurants focusing on authentic culinary experiences.</a:t>
+            </a:r>
+          </a:p>
+        </p:txBody>
+      </p:sp>
+      <p:sp>
+        <p:nvSpPr>
+          <p:cNvPr id="27" name="subtopic">
+            <a:extLst>
+              <a:ext uri="{FF2B5EF4-FFF2-40B4-BE49-F238E27FC236}">
+                <a16:creationId xmlns:a16="http://schemas.microsoft.com/office/drawing/2014/main" id="{1FC39E55-DAC2-4D18-8701-DF4E171179AC}"/>
+              </a:ext>
+            </a:extLst>
+          </p:cNvPr>
+          <p:cNvSpPr txBox="1"/>
+          <p:nvPr/>
+        </p:nvSpPr>
+        <p:spPr>
+          <a:xfrm>
+            <a:off x="168257" y="330442"/>
+            <a:ext cx="10563455" cy="646331"/>
+          </a:xfrm>
+          <a:prstGeom prst="rect">
+            <a:avLst/>
+          </a:prstGeom>
+          <a:noFill/>
+        </p:spPr>
+        <p:txBody>
+          <a:bodyPr wrap="square" rtlCol="0">
+            <a:spAutoFit/>
+          </a:bodyPr>
+          <a:lstStyle/>
+          <a:p>
+            <a:r>
+              <a:t>Signature Dishes: The Must-Try Foods Across the USA</a:t>
+            </a:r>
+          </a:p>
+        </p:txBody>
+      </p:sp>
+    </p:spTree>
+  </p:cSld>
+  <p:clrMapOvr>
+    <a:masterClrMapping/>
+  </p:clrMapOvr>
+</p:sld>
+</file>
+
+<file path=ppt/slides/slide4.xml><?xml version="1.0" encoding="utf-8"?>
+<p:sld xmlns:a="http://schemas.openxmlformats.org/drawingml/2006/main" xmlns:p="http://schemas.openxmlformats.org/presentationml/2006/main" xmlns:r="http://schemas.openxmlformats.org/officeDocument/2006/relationships">
+  <p:cSld>
+    <p:spTree>
+      <p:nvGrpSpPr>
+        <p:cNvPr id="1" name=""/>
+        <p:cNvGrpSpPr/>
+        <p:nvPr/>
+      </p:nvGrpSpPr>
+      <p:grpSpPr/>
+      <p:sp>
+        <p:nvSpPr>
           <p:cNvPr id="3" name="ending">
             <a:extLst>
               <a:ext uri="{FF2B5EF4-FFF2-40B4-BE49-F238E27FC236}">
@@ -3515,7 +3860,7 @@
           <a:lstStyle/>
           <a:p>
             <a:r>
-              <a:t>Ramen's journey from its origins to a global phenomenon showcases its rich cultural significance and ongoing evolution.</a:t>
+              <a:t>Thank you for exploring famous foods in USA.</a:t>
             </a:r>
           </a:p>
         </p:txBody>

</xml_diff>